<commit_message>
twpatron added to powerpoint
</commit_message>
<xml_diff>
--- a/SP3T-ECAL.pptx
+++ b/SP3T-ECAL.pptx
@@ -19,6 +19,8 @@
     <p:sldId id="267" r:id="rId13"/>
     <p:sldId id="268" r:id="rId14"/>
     <p:sldId id="269" r:id="rId15"/>
+    <p:sldId id="270" r:id="rId16"/>
+    <p:sldId id="271" r:id="rId17"/>
   </p:sldIdLst>
   <p:sldSz cx="12192000" cy="6858000"/>
   <p:notesSz cx="7023100" cy="9309100"/>
@@ -272,7 +274,7 @@
           <a:p>
             <a:fld id="{7053F05D-9385-4B1A-9374-4A2BEAD69DDD}" type="datetimeFigureOut">
               <a:rPr lang="en-US" smtClean="0"/>
-              <a:t>2/12/2026</a:t>
+              <a:t>3/3/2026</a:t>
             </a:fld>
             <a:endParaRPr lang="en-US"/>
           </a:p>
@@ -470,7 +472,7 @@
           <a:p>
             <a:fld id="{7053F05D-9385-4B1A-9374-4A2BEAD69DDD}" type="datetimeFigureOut">
               <a:rPr lang="en-US" smtClean="0"/>
-              <a:t>2/12/2026</a:t>
+              <a:t>3/3/2026</a:t>
             </a:fld>
             <a:endParaRPr lang="en-US"/>
           </a:p>
@@ -678,7 +680,7 @@
           <a:p>
             <a:fld id="{7053F05D-9385-4B1A-9374-4A2BEAD69DDD}" type="datetimeFigureOut">
               <a:rPr lang="en-US" smtClean="0"/>
-              <a:t>2/12/2026</a:t>
+              <a:t>3/3/2026</a:t>
             </a:fld>
             <a:endParaRPr lang="en-US"/>
           </a:p>
@@ -876,7 +878,7 @@
           <a:p>
             <a:fld id="{7053F05D-9385-4B1A-9374-4A2BEAD69DDD}" type="datetimeFigureOut">
               <a:rPr lang="en-US" smtClean="0"/>
-              <a:t>2/12/2026</a:t>
+              <a:t>3/3/2026</a:t>
             </a:fld>
             <a:endParaRPr lang="en-US"/>
           </a:p>
@@ -1151,7 +1153,7 @@
           <a:p>
             <a:fld id="{7053F05D-9385-4B1A-9374-4A2BEAD69DDD}" type="datetimeFigureOut">
               <a:rPr lang="en-US" smtClean="0"/>
-              <a:t>2/12/2026</a:t>
+              <a:t>3/3/2026</a:t>
             </a:fld>
             <a:endParaRPr lang="en-US"/>
           </a:p>
@@ -1416,7 +1418,7 @@
           <a:p>
             <a:fld id="{7053F05D-9385-4B1A-9374-4A2BEAD69DDD}" type="datetimeFigureOut">
               <a:rPr lang="en-US" smtClean="0"/>
-              <a:t>2/12/2026</a:t>
+              <a:t>3/3/2026</a:t>
             </a:fld>
             <a:endParaRPr lang="en-US"/>
           </a:p>
@@ -1828,7 +1830,7 @@
           <a:p>
             <a:fld id="{7053F05D-9385-4B1A-9374-4A2BEAD69DDD}" type="datetimeFigureOut">
               <a:rPr lang="en-US" smtClean="0"/>
-              <a:t>2/12/2026</a:t>
+              <a:t>3/3/2026</a:t>
             </a:fld>
             <a:endParaRPr lang="en-US"/>
           </a:p>
@@ -1969,7 +1971,7 @@
           <a:p>
             <a:fld id="{7053F05D-9385-4B1A-9374-4A2BEAD69DDD}" type="datetimeFigureOut">
               <a:rPr lang="en-US" smtClean="0"/>
-              <a:t>2/12/2026</a:t>
+              <a:t>3/3/2026</a:t>
             </a:fld>
             <a:endParaRPr lang="en-US"/>
           </a:p>
@@ -2082,7 +2084,7 @@
           <a:p>
             <a:fld id="{7053F05D-9385-4B1A-9374-4A2BEAD69DDD}" type="datetimeFigureOut">
               <a:rPr lang="en-US" smtClean="0"/>
-              <a:t>2/12/2026</a:t>
+              <a:t>3/3/2026</a:t>
             </a:fld>
             <a:endParaRPr lang="en-US"/>
           </a:p>
@@ -2393,7 +2395,7 @@
           <a:p>
             <a:fld id="{7053F05D-9385-4B1A-9374-4A2BEAD69DDD}" type="datetimeFigureOut">
               <a:rPr lang="en-US" smtClean="0"/>
-              <a:t>2/12/2026</a:t>
+              <a:t>3/3/2026</a:t>
             </a:fld>
             <a:endParaRPr lang="en-US"/>
           </a:p>
@@ -2681,7 +2683,7 @@
           <a:p>
             <a:fld id="{7053F05D-9385-4B1A-9374-4A2BEAD69DDD}" type="datetimeFigureOut">
               <a:rPr lang="en-US" smtClean="0"/>
-              <a:t>2/12/2026</a:t>
+              <a:t>3/3/2026</a:t>
             </a:fld>
             <a:endParaRPr lang="en-US"/>
           </a:p>
@@ -2922,7 +2924,7 @@
           <a:p>
             <a:fld id="{7053F05D-9385-4B1A-9374-4A2BEAD69DDD}" type="datetimeFigureOut">
               <a:rPr lang="en-US" smtClean="0"/>
-              <a:t>2/12/2026</a:t>
+              <a:t>3/3/2026</a:t>
             </a:fld>
             <a:endParaRPr lang="en-US"/>
           </a:p>
@@ -3662,8 +3664,8 @@
           </a:p>
         </p:txBody>
       </p:sp>
-      <mc:AlternateContent xmlns:mc="http://schemas.openxmlformats.org/markup-compatibility/2006">
-        <mc:Choice xmlns:a14="http://schemas.microsoft.com/office/drawing/2010/main" Requires="a14">
+      <mc:AlternateContent xmlns:mc="http://schemas.openxmlformats.org/markup-compatibility/2006" xmlns:a14="http://schemas.microsoft.com/office/drawing/2010/main">
+        <mc:Choice Requires="a14">
           <p:sp>
             <p:nvSpPr>
               <p:cNvPr id="11" name="TextBox 10">
@@ -3765,7 +3767,7 @@
             </p:txBody>
           </p:sp>
         </mc:Choice>
-        <mc:Fallback>
+        <mc:Fallback xmlns="">
           <p:sp>
             <p:nvSpPr>
               <p:cNvPr id="11" name="TextBox 10">
@@ -5542,6 +5544,251 @@
     <p:extLst>
       <p:ext uri="{BB962C8B-B14F-4D97-AF65-F5344CB8AC3E}">
         <p14:creationId xmlns:p14="http://schemas.microsoft.com/office/powerpoint/2010/main" val="2483358830"/>
+      </p:ext>
+    </p:extLst>
+  </p:cSld>
+  <p:clrMapOvr>
+    <a:masterClrMapping/>
+  </p:clrMapOvr>
+</p:sld>
+</file>
+
+<file path=ppt/slides/slide15.xml><?xml version="1.0" encoding="utf-8"?>
+<p:sld xmlns:a="http://schemas.openxmlformats.org/drawingml/2006/main" xmlns:r="http://schemas.openxmlformats.org/officeDocument/2006/relationships" xmlns:p="http://schemas.openxmlformats.org/presentationml/2006/main">
+  <p:cSld>
+    <p:spTree>
+      <p:nvGrpSpPr>
+        <p:cNvPr id="1" name=""/>
+        <p:cNvGrpSpPr/>
+        <p:nvPr/>
+      </p:nvGrpSpPr>
+      <p:grpSpPr>
+        <a:xfrm>
+          <a:off x="0" y="0"/>
+          <a:ext cx="0" cy="0"/>
+          <a:chOff x="0" y="0"/>
+          <a:chExt cx="0" cy="0"/>
+        </a:xfrm>
+      </p:grpSpPr>
+      <p:sp>
+        <p:nvSpPr>
+          <p:cNvPr id="2" name="Title 1">
+            <a:extLst>
+              <a:ext uri="{FF2B5EF4-FFF2-40B4-BE49-F238E27FC236}">
+                <a16:creationId xmlns:a16="http://schemas.microsoft.com/office/drawing/2014/main" id="{10B1305F-549F-3458-105C-DAA5A1A74D0C}"/>
+              </a:ext>
+            </a:extLst>
+          </p:cNvPr>
+          <p:cNvSpPr>
+            <a:spLocks noGrp="1"/>
+          </p:cNvSpPr>
+          <p:nvPr>
+            <p:ph type="title"/>
+          </p:nvPr>
+        </p:nvSpPr>
+        <p:spPr/>
+        <p:txBody>
+          <a:bodyPr/>
+          <a:lstStyle/>
+          <a:p>
+            <a:r>
+              <a:rPr lang="en-US" dirty="0"/>
+              <a:t>Rough draft of layout topology</a:t>
+            </a:r>
+          </a:p>
+        </p:txBody>
+      </p:sp>
+      <p:pic>
+        <p:nvPicPr>
+          <p:cNvPr id="8" name="Picture 7">
+            <a:extLst>
+              <a:ext uri="{FF2B5EF4-FFF2-40B4-BE49-F238E27FC236}">
+                <a16:creationId xmlns:a16="http://schemas.microsoft.com/office/drawing/2014/main" id="{593B4F7C-9C21-9AED-874D-B9C316BDE937}"/>
+              </a:ext>
+            </a:extLst>
+          </p:cNvPr>
+          <p:cNvPicPr>
+            <a:picLocks noChangeAspect="1"/>
+          </p:cNvPicPr>
+          <p:nvPr/>
+        </p:nvPicPr>
+        <p:blipFill>
+          <a:blip r:embed="rId2"/>
+          <a:stretch>
+            <a:fillRect/>
+          </a:stretch>
+        </p:blipFill>
+        <p:spPr>
+          <a:xfrm rot="16200000">
+            <a:off x="2592740" y="1601953"/>
+            <a:ext cx="4255291" cy="4659543"/>
+          </a:xfrm>
+          <a:prstGeom prst="rect">
+            <a:avLst/>
+          </a:prstGeom>
+        </p:spPr>
+      </p:pic>
+      <p:pic>
+        <p:nvPicPr>
+          <p:cNvPr id="9" name="Picture 8">
+            <a:extLst>
+              <a:ext uri="{FF2B5EF4-FFF2-40B4-BE49-F238E27FC236}">
+                <a16:creationId xmlns:a16="http://schemas.microsoft.com/office/drawing/2014/main" id="{D080B772-64DA-481C-597C-810659735985}"/>
+              </a:ext>
+            </a:extLst>
+          </p:cNvPr>
+          <p:cNvPicPr>
+            <a:picLocks noChangeAspect="1"/>
+          </p:cNvPicPr>
+          <p:nvPr/>
+        </p:nvPicPr>
+        <p:blipFill>
+          <a:blip r:embed="rId2"/>
+          <a:srcRect t="1" b="27360"/>
+          <a:stretch>
+            <a:fillRect/>
+          </a:stretch>
+        </p:blipFill>
+        <p:spPr>
+          <a:xfrm rot="5400000">
+            <a:off x="6267627" y="2126011"/>
+            <a:ext cx="4255291" cy="3384645"/>
+          </a:xfrm>
+          <a:prstGeom prst="rect">
+            <a:avLst/>
+          </a:prstGeom>
+        </p:spPr>
+      </p:pic>
+    </p:spTree>
+    <p:extLst>
+      <p:ext uri="{BB962C8B-B14F-4D97-AF65-F5344CB8AC3E}">
+        <p14:creationId xmlns:p14="http://schemas.microsoft.com/office/powerpoint/2010/main" val="2215164839"/>
+      </p:ext>
+    </p:extLst>
+  </p:cSld>
+  <p:clrMapOvr>
+    <a:masterClrMapping/>
+  </p:clrMapOvr>
+</p:sld>
+</file>
+
+<file path=ppt/slides/slide16.xml><?xml version="1.0" encoding="utf-8"?>
+<p:sld xmlns:a="http://schemas.openxmlformats.org/drawingml/2006/main" xmlns:r="http://schemas.openxmlformats.org/officeDocument/2006/relationships" xmlns:p="http://schemas.openxmlformats.org/presentationml/2006/main">
+  <p:cSld>
+    <p:spTree>
+      <p:nvGrpSpPr>
+        <p:cNvPr id="1" name=""/>
+        <p:cNvGrpSpPr/>
+        <p:nvPr/>
+      </p:nvGrpSpPr>
+      <p:grpSpPr>
+        <a:xfrm>
+          <a:off x="0" y="0"/>
+          <a:ext cx="0" cy="0"/>
+          <a:chOff x="0" y="0"/>
+          <a:chExt cx="0" cy="0"/>
+        </a:xfrm>
+      </p:grpSpPr>
+      <p:sp>
+        <p:nvSpPr>
+          <p:cNvPr id="2" name="Title 1">
+            <a:extLst>
+              <a:ext uri="{FF2B5EF4-FFF2-40B4-BE49-F238E27FC236}">
+                <a16:creationId xmlns:a16="http://schemas.microsoft.com/office/drawing/2014/main" id="{170E54A4-BD03-A967-DC6D-C3B64CADB91F}"/>
+              </a:ext>
+            </a:extLst>
+          </p:cNvPr>
+          <p:cNvSpPr>
+            <a:spLocks noGrp="1"/>
+          </p:cNvSpPr>
+          <p:nvPr>
+            <p:ph type="title"/>
+          </p:nvPr>
+        </p:nvSpPr>
+        <p:spPr/>
+        <p:txBody>
+          <a:bodyPr/>
+          <a:lstStyle/>
+          <a:p>
+            <a:r>
+              <a:rPr lang="en-US" dirty="0" err="1"/>
+              <a:t>TWPAtron</a:t>
+            </a:r>
+            <a:r>
+              <a:rPr lang="en-US" dirty="0"/>
+              <a:t> rough </a:t>
+            </a:r>
+            <a:r>
+              <a:rPr lang="en-US"/>
+              <a:t>layout topology</a:t>
+            </a:r>
+          </a:p>
+        </p:txBody>
+      </p:sp>
+      <p:pic>
+        <p:nvPicPr>
+          <p:cNvPr id="5" name="Picture 4">
+            <a:extLst>
+              <a:ext uri="{FF2B5EF4-FFF2-40B4-BE49-F238E27FC236}">
+                <a16:creationId xmlns:a16="http://schemas.microsoft.com/office/drawing/2014/main" id="{042E6543-36E8-1B26-41CD-638584F69FD5}"/>
+              </a:ext>
+            </a:extLst>
+          </p:cNvPr>
+          <p:cNvPicPr>
+            <a:picLocks noChangeAspect="1"/>
+          </p:cNvPicPr>
+          <p:nvPr/>
+        </p:nvPicPr>
+        <p:blipFill>
+          <a:blip r:embed="rId2"/>
+          <a:stretch>
+            <a:fillRect/>
+          </a:stretch>
+        </p:blipFill>
+        <p:spPr>
+          <a:xfrm>
+            <a:off x="178973" y="2399137"/>
+            <a:ext cx="5917027" cy="3150323"/>
+          </a:xfrm>
+          <a:prstGeom prst="rect">
+            <a:avLst/>
+          </a:prstGeom>
+        </p:spPr>
+      </p:pic>
+      <p:pic>
+        <p:nvPicPr>
+          <p:cNvPr id="7" name="Picture 6">
+            <a:extLst>
+              <a:ext uri="{FF2B5EF4-FFF2-40B4-BE49-F238E27FC236}">
+                <a16:creationId xmlns:a16="http://schemas.microsoft.com/office/drawing/2014/main" id="{87F4260E-F19A-325B-7B0A-73612E67864B}"/>
+              </a:ext>
+            </a:extLst>
+          </p:cNvPr>
+          <p:cNvPicPr>
+            <a:picLocks noChangeAspect="1"/>
+          </p:cNvPicPr>
+          <p:nvPr/>
+        </p:nvPicPr>
+        <p:blipFill>
+          <a:blip r:embed="rId3"/>
+          <a:stretch>
+            <a:fillRect/>
+          </a:stretch>
+        </p:blipFill>
+        <p:spPr>
+          <a:xfrm>
+            <a:off x="6096000" y="2694263"/>
+            <a:ext cx="5746143" cy="2950839"/>
+          </a:xfrm>
+          <a:prstGeom prst="rect">
+            <a:avLst/>
+          </a:prstGeom>
+        </p:spPr>
+      </p:pic>
+    </p:spTree>
+    <p:extLst>
+      <p:ext uri="{BB962C8B-B14F-4D97-AF65-F5344CB8AC3E}">
+        <p14:creationId xmlns:p14="http://schemas.microsoft.com/office/powerpoint/2010/main" val="505348996"/>
       </p:ext>
     </p:extLst>
   </p:cSld>

</xml_diff>

<commit_message>
twpatron2 close to a full draft
</commit_message>
<xml_diff>
--- a/SP3T-ECAL.pptx
+++ b/SP3T-ECAL.pptx
@@ -22,6 +22,7 @@
     <p:sldId id="270" r:id="rId16"/>
     <p:sldId id="271" r:id="rId17"/>
     <p:sldId id="272" r:id="rId18"/>
+    <p:sldId id="273" r:id="rId19"/>
   </p:sldIdLst>
   <p:sldSz cx="12192000" cy="6858000"/>
   <p:notesSz cx="7023100" cy="9309100"/>
@@ -275,7 +276,7 @@
           <a:p>
             <a:fld id="{7053F05D-9385-4B1A-9374-4A2BEAD69DDD}" type="datetimeFigureOut">
               <a:rPr lang="en-US" smtClean="0"/>
-              <a:t>3/4/2026</a:t>
+              <a:t>3/5/2026</a:t>
             </a:fld>
             <a:endParaRPr lang="en-US"/>
           </a:p>
@@ -473,7 +474,7 @@
           <a:p>
             <a:fld id="{7053F05D-9385-4B1A-9374-4A2BEAD69DDD}" type="datetimeFigureOut">
               <a:rPr lang="en-US" smtClean="0"/>
-              <a:t>3/4/2026</a:t>
+              <a:t>3/5/2026</a:t>
             </a:fld>
             <a:endParaRPr lang="en-US"/>
           </a:p>
@@ -681,7 +682,7 @@
           <a:p>
             <a:fld id="{7053F05D-9385-4B1A-9374-4A2BEAD69DDD}" type="datetimeFigureOut">
               <a:rPr lang="en-US" smtClean="0"/>
-              <a:t>3/4/2026</a:t>
+              <a:t>3/5/2026</a:t>
             </a:fld>
             <a:endParaRPr lang="en-US"/>
           </a:p>
@@ -879,7 +880,7 @@
           <a:p>
             <a:fld id="{7053F05D-9385-4B1A-9374-4A2BEAD69DDD}" type="datetimeFigureOut">
               <a:rPr lang="en-US" smtClean="0"/>
-              <a:t>3/4/2026</a:t>
+              <a:t>3/5/2026</a:t>
             </a:fld>
             <a:endParaRPr lang="en-US"/>
           </a:p>
@@ -1154,7 +1155,7 @@
           <a:p>
             <a:fld id="{7053F05D-9385-4B1A-9374-4A2BEAD69DDD}" type="datetimeFigureOut">
               <a:rPr lang="en-US" smtClean="0"/>
-              <a:t>3/4/2026</a:t>
+              <a:t>3/5/2026</a:t>
             </a:fld>
             <a:endParaRPr lang="en-US"/>
           </a:p>
@@ -1419,7 +1420,7 @@
           <a:p>
             <a:fld id="{7053F05D-9385-4B1A-9374-4A2BEAD69DDD}" type="datetimeFigureOut">
               <a:rPr lang="en-US" smtClean="0"/>
-              <a:t>3/4/2026</a:t>
+              <a:t>3/5/2026</a:t>
             </a:fld>
             <a:endParaRPr lang="en-US"/>
           </a:p>
@@ -1831,7 +1832,7 @@
           <a:p>
             <a:fld id="{7053F05D-9385-4B1A-9374-4A2BEAD69DDD}" type="datetimeFigureOut">
               <a:rPr lang="en-US" smtClean="0"/>
-              <a:t>3/4/2026</a:t>
+              <a:t>3/5/2026</a:t>
             </a:fld>
             <a:endParaRPr lang="en-US"/>
           </a:p>
@@ -1972,7 +1973,7 @@
           <a:p>
             <a:fld id="{7053F05D-9385-4B1A-9374-4A2BEAD69DDD}" type="datetimeFigureOut">
               <a:rPr lang="en-US" smtClean="0"/>
-              <a:t>3/4/2026</a:t>
+              <a:t>3/5/2026</a:t>
             </a:fld>
             <a:endParaRPr lang="en-US"/>
           </a:p>
@@ -2085,7 +2086,7 @@
           <a:p>
             <a:fld id="{7053F05D-9385-4B1A-9374-4A2BEAD69DDD}" type="datetimeFigureOut">
               <a:rPr lang="en-US" smtClean="0"/>
-              <a:t>3/4/2026</a:t>
+              <a:t>3/5/2026</a:t>
             </a:fld>
             <a:endParaRPr lang="en-US"/>
           </a:p>
@@ -2396,7 +2397,7 @@
           <a:p>
             <a:fld id="{7053F05D-9385-4B1A-9374-4A2BEAD69DDD}" type="datetimeFigureOut">
               <a:rPr lang="en-US" smtClean="0"/>
-              <a:t>3/4/2026</a:t>
+              <a:t>3/5/2026</a:t>
             </a:fld>
             <a:endParaRPr lang="en-US"/>
           </a:p>
@@ -2684,7 +2685,7 @@
           <a:p>
             <a:fld id="{7053F05D-9385-4B1A-9374-4A2BEAD69DDD}" type="datetimeFigureOut">
               <a:rPr lang="en-US" smtClean="0"/>
-              <a:t>3/4/2026</a:t>
+              <a:t>3/5/2026</a:t>
             </a:fld>
             <a:endParaRPr lang="en-US"/>
           </a:p>
@@ -2925,7 +2926,7 @@
           <a:p>
             <a:fld id="{7053F05D-9385-4B1A-9374-4A2BEAD69DDD}" type="datetimeFigureOut">
               <a:rPr lang="en-US" smtClean="0"/>
-              <a:t>3/4/2026</a:t>
+              <a:t>3/5/2026</a:t>
             </a:fld>
             <a:endParaRPr lang="en-US"/>
           </a:p>
@@ -5979,6 +5980,94 @@
     <p:extLst>
       <p:ext uri="{BB962C8B-B14F-4D97-AF65-F5344CB8AC3E}">
         <p14:creationId xmlns:p14="http://schemas.microsoft.com/office/powerpoint/2010/main" val="2932968411"/>
+      </p:ext>
+    </p:extLst>
+  </p:cSld>
+  <p:clrMapOvr>
+    <a:masterClrMapping/>
+  </p:clrMapOvr>
+</p:sld>
+</file>
+
+<file path=ppt/slides/slide18.xml><?xml version="1.0" encoding="utf-8"?>
+<p:sld xmlns:a="http://schemas.openxmlformats.org/drawingml/2006/main" xmlns:r="http://schemas.openxmlformats.org/officeDocument/2006/relationships" xmlns:p="http://schemas.openxmlformats.org/presentationml/2006/main">
+  <p:cSld>
+    <p:spTree>
+      <p:nvGrpSpPr>
+        <p:cNvPr id="1" name=""/>
+        <p:cNvGrpSpPr/>
+        <p:nvPr/>
+      </p:nvGrpSpPr>
+      <p:grpSpPr>
+        <a:xfrm>
+          <a:off x="0" y="0"/>
+          <a:ext cx="0" cy="0"/>
+          <a:chOff x="0" y="0"/>
+          <a:chExt cx="0" cy="0"/>
+        </a:xfrm>
+      </p:grpSpPr>
+      <p:sp>
+        <p:nvSpPr>
+          <p:cNvPr id="2" name="Title 1">
+            <a:extLst>
+              <a:ext uri="{FF2B5EF4-FFF2-40B4-BE49-F238E27FC236}">
+                <a16:creationId xmlns:a16="http://schemas.microsoft.com/office/drawing/2014/main" id="{985A17EC-50FB-D0F5-8BB8-AC90C8226599}"/>
+              </a:ext>
+            </a:extLst>
+          </p:cNvPr>
+          <p:cNvSpPr>
+            <a:spLocks noGrp="1"/>
+          </p:cNvSpPr>
+          <p:nvPr>
+            <p:ph type="title"/>
+          </p:nvPr>
+        </p:nvSpPr>
+        <p:spPr/>
+        <p:txBody>
+          <a:bodyPr/>
+          <a:lstStyle/>
+          <a:p>
+            <a:r>
+              <a:rPr lang="en-US" dirty="0"/>
+              <a:t>3d render of latest draft</a:t>
+            </a:r>
+          </a:p>
+        </p:txBody>
+      </p:sp>
+      <p:pic>
+        <p:nvPicPr>
+          <p:cNvPr id="9" name="Picture 8">
+            <a:extLst>
+              <a:ext uri="{FF2B5EF4-FFF2-40B4-BE49-F238E27FC236}">
+                <a16:creationId xmlns:a16="http://schemas.microsoft.com/office/drawing/2014/main" id="{1F7AA443-E775-6B93-F61B-7708584FCEEA}"/>
+              </a:ext>
+            </a:extLst>
+          </p:cNvPr>
+          <p:cNvPicPr>
+            <a:picLocks noChangeAspect="1"/>
+          </p:cNvPicPr>
+          <p:nvPr/>
+        </p:nvPicPr>
+        <p:blipFill>
+          <a:blip r:embed="rId2"/>
+          <a:stretch>
+            <a:fillRect/>
+          </a:stretch>
+        </p:blipFill>
+        <p:spPr>
+          <a:xfrm>
+            <a:off x="1854942" y="1792960"/>
+            <a:ext cx="8164064" cy="4401164"/>
+          </a:xfrm>
+          <a:prstGeom prst="rect">
+            <a:avLst/>
+          </a:prstGeom>
+        </p:spPr>
+      </p:pic>
+    </p:spTree>
+    <p:extLst>
+      <p:ext uri="{BB962C8B-B14F-4D97-AF65-F5344CB8AC3E}">
+        <p14:creationId xmlns:p14="http://schemas.microsoft.com/office/powerpoint/2010/main" val="1480082919"/>
       </p:ext>
     </p:extLst>
   </p:cSld>

</xml_diff>

<commit_message>
a full draft of pcb is essentially done now
</commit_message>
<xml_diff>
--- a/SP3T-ECAL.pptx
+++ b/SP3T-ECAL.pptx
@@ -26,6 +26,8 @@
     <p:sldId id="274" r:id="rId20"/>
     <p:sldId id="275" r:id="rId21"/>
     <p:sldId id="276" r:id="rId22"/>
+    <p:sldId id="277" r:id="rId23"/>
+    <p:sldId id="278" r:id="rId24"/>
   </p:sldIdLst>
   <p:sldSz cx="12192000" cy="6858000"/>
   <p:notesSz cx="7023100" cy="9309100"/>
@@ -279,7 +281,7 @@
           <a:p>
             <a:fld id="{7053F05D-9385-4B1A-9374-4A2BEAD69DDD}" type="datetimeFigureOut">
               <a:rPr lang="en-US" smtClean="0"/>
-              <a:t>3/6/2026</a:t>
+              <a:t>3/9/2026</a:t>
             </a:fld>
             <a:endParaRPr lang="en-US"/>
           </a:p>
@@ -477,7 +479,7 @@
           <a:p>
             <a:fld id="{7053F05D-9385-4B1A-9374-4A2BEAD69DDD}" type="datetimeFigureOut">
               <a:rPr lang="en-US" smtClean="0"/>
-              <a:t>3/6/2026</a:t>
+              <a:t>3/9/2026</a:t>
             </a:fld>
             <a:endParaRPr lang="en-US"/>
           </a:p>
@@ -685,7 +687,7 @@
           <a:p>
             <a:fld id="{7053F05D-9385-4B1A-9374-4A2BEAD69DDD}" type="datetimeFigureOut">
               <a:rPr lang="en-US" smtClean="0"/>
-              <a:t>3/6/2026</a:t>
+              <a:t>3/9/2026</a:t>
             </a:fld>
             <a:endParaRPr lang="en-US"/>
           </a:p>
@@ -883,7 +885,7 @@
           <a:p>
             <a:fld id="{7053F05D-9385-4B1A-9374-4A2BEAD69DDD}" type="datetimeFigureOut">
               <a:rPr lang="en-US" smtClean="0"/>
-              <a:t>3/6/2026</a:t>
+              <a:t>3/9/2026</a:t>
             </a:fld>
             <a:endParaRPr lang="en-US"/>
           </a:p>
@@ -1158,7 +1160,7 @@
           <a:p>
             <a:fld id="{7053F05D-9385-4B1A-9374-4A2BEAD69DDD}" type="datetimeFigureOut">
               <a:rPr lang="en-US" smtClean="0"/>
-              <a:t>3/6/2026</a:t>
+              <a:t>3/9/2026</a:t>
             </a:fld>
             <a:endParaRPr lang="en-US"/>
           </a:p>
@@ -1423,7 +1425,7 @@
           <a:p>
             <a:fld id="{7053F05D-9385-4B1A-9374-4A2BEAD69DDD}" type="datetimeFigureOut">
               <a:rPr lang="en-US" smtClean="0"/>
-              <a:t>3/6/2026</a:t>
+              <a:t>3/9/2026</a:t>
             </a:fld>
             <a:endParaRPr lang="en-US"/>
           </a:p>
@@ -1835,7 +1837,7 @@
           <a:p>
             <a:fld id="{7053F05D-9385-4B1A-9374-4A2BEAD69DDD}" type="datetimeFigureOut">
               <a:rPr lang="en-US" smtClean="0"/>
-              <a:t>3/6/2026</a:t>
+              <a:t>3/9/2026</a:t>
             </a:fld>
             <a:endParaRPr lang="en-US"/>
           </a:p>
@@ -1976,7 +1978,7 @@
           <a:p>
             <a:fld id="{7053F05D-9385-4B1A-9374-4A2BEAD69DDD}" type="datetimeFigureOut">
               <a:rPr lang="en-US" smtClean="0"/>
-              <a:t>3/6/2026</a:t>
+              <a:t>3/9/2026</a:t>
             </a:fld>
             <a:endParaRPr lang="en-US"/>
           </a:p>
@@ -2089,7 +2091,7 @@
           <a:p>
             <a:fld id="{7053F05D-9385-4B1A-9374-4A2BEAD69DDD}" type="datetimeFigureOut">
               <a:rPr lang="en-US" smtClean="0"/>
-              <a:t>3/6/2026</a:t>
+              <a:t>3/9/2026</a:t>
             </a:fld>
             <a:endParaRPr lang="en-US"/>
           </a:p>
@@ -2400,7 +2402,7 @@
           <a:p>
             <a:fld id="{7053F05D-9385-4B1A-9374-4A2BEAD69DDD}" type="datetimeFigureOut">
               <a:rPr lang="en-US" smtClean="0"/>
-              <a:t>3/6/2026</a:t>
+              <a:t>3/9/2026</a:t>
             </a:fld>
             <a:endParaRPr lang="en-US"/>
           </a:p>
@@ -2688,7 +2690,7 @@
           <a:p>
             <a:fld id="{7053F05D-9385-4B1A-9374-4A2BEAD69DDD}" type="datetimeFigureOut">
               <a:rPr lang="en-US" smtClean="0"/>
-              <a:t>3/6/2026</a:t>
+              <a:t>3/9/2026</a:t>
             </a:fld>
             <a:endParaRPr lang="en-US"/>
           </a:p>
@@ -2929,7 +2931,7 @@
           <a:p>
             <a:fld id="{7053F05D-9385-4B1A-9374-4A2BEAD69DDD}" type="datetimeFigureOut">
               <a:rPr lang="en-US" smtClean="0"/>
-              <a:t>3/6/2026</a:t>
+              <a:t>3/9/2026</a:t>
             </a:fld>
             <a:endParaRPr lang="en-US"/>
           </a:p>
@@ -6503,6 +6505,901 @@
     <p:extLst>
       <p:ext uri="{BB962C8B-B14F-4D97-AF65-F5344CB8AC3E}">
         <p14:creationId xmlns:p14="http://schemas.microsoft.com/office/powerpoint/2010/main" val="4202014146"/>
+      </p:ext>
+    </p:extLst>
+  </p:cSld>
+  <p:clrMapOvr>
+    <a:masterClrMapping/>
+  </p:clrMapOvr>
+</p:sld>
+</file>
+
+<file path=ppt/slides/slide22.xml><?xml version="1.0" encoding="utf-8"?>
+<p:sld xmlns:a="http://schemas.openxmlformats.org/drawingml/2006/main" xmlns:r="http://schemas.openxmlformats.org/officeDocument/2006/relationships" xmlns:p="http://schemas.openxmlformats.org/presentationml/2006/main">
+  <p:cSld>
+    <p:spTree>
+      <p:nvGrpSpPr>
+        <p:cNvPr id="1" name=""/>
+        <p:cNvGrpSpPr/>
+        <p:nvPr/>
+      </p:nvGrpSpPr>
+      <p:grpSpPr>
+        <a:xfrm>
+          <a:off x="0" y="0"/>
+          <a:ext cx="0" cy="0"/>
+          <a:chOff x="0" y="0"/>
+          <a:chExt cx="0" cy="0"/>
+        </a:xfrm>
+      </p:grpSpPr>
+      <p:pic>
+        <p:nvPicPr>
+          <p:cNvPr id="5" name="Picture 4">
+            <a:extLst>
+              <a:ext uri="{FF2B5EF4-FFF2-40B4-BE49-F238E27FC236}">
+                <a16:creationId xmlns:a16="http://schemas.microsoft.com/office/drawing/2014/main" id="{DBC76C2C-5F1C-0B13-A266-0E01EB6CFE82}"/>
+              </a:ext>
+            </a:extLst>
+          </p:cNvPr>
+          <p:cNvPicPr>
+            <a:picLocks noChangeAspect="1"/>
+          </p:cNvPicPr>
+          <p:nvPr/>
+        </p:nvPicPr>
+        <p:blipFill>
+          <a:blip r:embed="rId2"/>
+          <a:stretch>
+            <a:fillRect/>
+          </a:stretch>
+        </p:blipFill>
+        <p:spPr>
+          <a:xfrm>
+            <a:off x="2776074" y="1015574"/>
+            <a:ext cx="6639852" cy="4715533"/>
+          </a:xfrm>
+          <a:prstGeom prst="rect">
+            <a:avLst/>
+          </a:prstGeom>
+        </p:spPr>
+      </p:pic>
+      <p:cxnSp>
+        <p:nvCxnSpPr>
+          <p:cNvPr id="7" name="Straight Arrow Connector 6">
+            <a:extLst>
+              <a:ext uri="{FF2B5EF4-FFF2-40B4-BE49-F238E27FC236}">
+                <a16:creationId xmlns:a16="http://schemas.microsoft.com/office/drawing/2014/main" id="{024C6CA5-9C44-78AD-2EF2-0F676B4586FC}"/>
+              </a:ext>
+            </a:extLst>
+          </p:cNvPr>
+          <p:cNvCxnSpPr/>
+          <p:nvPr/>
+        </p:nvCxnSpPr>
+        <p:spPr>
+          <a:xfrm>
+            <a:off x="1812897" y="2385391"/>
+            <a:ext cx="2130950" cy="612251"/>
+          </a:xfrm>
+          <a:prstGeom prst="straightConnector1">
+            <a:avLst/>
+          </a:prstGeom>
+          <a:ln w="44450" cap="flat" cmpd="sng" algn="ctr">
+            <a:solidFill>
+              <a:schemeClr val="accent4"/>
+            </a:solidFill>
+            <a:prstDash val="solid"/>
+            <a:round/>
+            <a:headEnd type="none" w="med" len="med"/>
+            <a:tailEnd type="arrow" w="med" len="med"/>
+          </a:ln>
+        </p:spPr>
+        <p:style>
+          <a:lnRef idx="0">
+            <a:scrgbClr r="0" g="0" b="0"/>
+          </a:lnRef>
+          <a:fillRef idx="0">
+            <a:scrgbClr r="0" g="0" b="0"/>
+          </a:fillRef>
+          <a:effectRef idx="0">
+            <a:scrgbClr r="0" g="0" b="0"/>
+          </a:effectRef>
+          <a:fontRef idx="minor">
+            <a:schemeClr val="tx1"/>
+          </a:fontRef>
+        </p:style>
+      </p:cxnSp>
+      <p:sp>
+        <p:nvSpPr>
+          <p:cNvPr id="8" name="TextBox 7">
+            <a:extLst>
+              <a:ext uri="{FF2B5EF4-FFF2-40B4-BE49-F238E27FC236}">
+                <a16:creationId xmlns:a16="http://schemas.microsoft.com/office/drawing/2014/main" id="{9CB61477-92AE-A388-7256-CDA48C99FAF8}"/>
+              </a:ext>
+            </a:extLst>
+          </p:cNvPr>
+          <p:cNvSpPr txBox="1"/>
+          <p:nvPr/>
+        </p:nvSpPr>
+        <p:spPr>
+          <a:xfrm>
+            <a:off x="471102" y="2016059"/>
+            <a:ext cx="1823384" cy="369332"/>
+          </a:xfrm>
+          <a:prstGeom prst="rect">
+            <a:avLst/>
+          </a:prstGeom>
+          <a:noFill/>
+        </p:spPr>
+        <p:txBody>
+          <a:bodyPr wrap="none" rtlCol="0">
+            <a:spAutoFit/>
+          </a:bodyPr>
+          <a:lstStyle/>
+          <a:p>
+            <a:r>
+              <a:rPr lang="en-US" dirty="0"/>
+              <a:t>Diameter 0.131”</a:t>
+            </a:r>
+          </a:p>
+        </p:txBody>
+      </p:sp>
+      <p:cxnSp>
+        <p:nvCxnSpPr>
+          <p:cNvPr id="9" name="Straight Arrow Connector 8">
+            <a:extLst>
+              <a:ext uri="{FF2B5EF4-FFF2-40B4-BE49-F238E27FC236}">
+                <a16:creationId xmlns:a16="http://schemas.microsoft.com/office/drawing/2014/main" id="{36FF4D4F-D610-BA55-2355-32C1ACA394ED}"/>
+              </a:ext>
+            </a:extLst>
+          </p:cNvPr>
+          <p:cNvCxnSpPr>
+            <a:cxnSpLocks/>
+            <a:stCxn id="11" idx="3"/>
+          </p:cNvCxnSpPr>
+          <p:nvPr/>
+        </p:nvCxnSpPr>
+        <p:spPr>
+          <a:xfrm>
+            <a:off x="2119906" y="3207937"/>
+            <a:ext cx="2103302" cy="221063"/>
+          </a:xfrm>
+          <a:prstGeom prst="straightConnector1">
+            <a:avLst/>
+          </a:prstGeom>
+          <a:ln w="44450" cap="flat" cmpd="sng" algn="ctr">
+            <a:solidFill>
+              <a:schemeClr val="accent4"/>
+            </a:solidFill>
+            <a:prstDash val="solid"/>
+            <a:round/>
+            <a:headEnd type="none" w="med" len="med"/>
+            <a:tailEnd type="arrow" w="med" len="med"/>
+          </a:ln>
+        </p:spPr>
+        <p:style>
+          <a:lnRef idx="0">
+            <a:scrgbClr r="0" g="0" b="0"/>
+          </a:lnRef>
+          <a:fillRef idx="0">
+            <a:scrgbClr r="0" g="0" b="0"/>
+          </a:fillRef>
+          <a:effectRef idx="0">
+            <a:scrgbClr r="0" g="0" b="0"/>
+          </a:effectRef>
+          <a:fontRef idx="minor">
+            <a:schemeClr val="tx1"/>
+          </a:fontRef>
+        </p:style>
+      </p:cxnSp>
+      <p:sp>
+        <p:nvSpPr>
+          <p:cNvPr id="11" name="TextBox 10">
+            <a:extLst>
+              <a:ext uri="{FF2B5EF4-FFF2-40B4-BE49-F238E27FC236}">
+                <a16:creationId xmlns:a16="http://schemas.microsoft.com/office/drawing/2014/main" id="{CB241BFA-597B-83CA-5FAA-958CD409428F}"/>
+              </a:ext>
+            </a:extLst>
+          </p:cNvPr>
+          <p:cNvSpPr txBox="1"/>
+          <p:nvPr/>
+        </p:nvSpPr>
+        <p:spPr>
+          <a:xfrm>
+            <a:off x="419953" y="3023271"/>
+            <a:ext cx="1699953" cy="369332"/>
+          </a:xfrm>
+          <a:prstGeom prst="rect">
+            <a:avLst/>
+          </a:prstGeom>
+          <a:noFill/>
+        </p:spPr>
+        <p:txBody>
+          <a:bodyPr wrap="none" rtlCol="0">
+            <a:spAutoFit/>
+          </a:bodyPr>
+          <a:lstStyle/>
+          <a:p>
+            <a:r>
+              <a:rPr lang="en-US" dirty="0"/>
+              <a:t>Diameter 0.08”</a:t>
+            </a:r>
+          </a:p>
+        </p:txBody>
+      </p:sp>
+      <p:cxnSp>
+        <p:nvCxnSpPr>
+          <p:cNvPr id="14" name="Straight Arrow Connector 13">
+            <a:extLst>
+              <a:ext uri="{FF2B5EF4-FFF2-40B4-BE49-F238E27FC236}">
+                <a16:creationId xmlns:a16="http://schemas.microsoft.com/office/drawing/2014/main" id="{94AAD7C9-A20F-1E5E-757D-C1747F935C55}"/>
+              </a:ext>
+            </a:extLst>
+          </p:cNvPr>
+          <p:cNvCxnSpPr/>
+          <p:nvPr/>
+        </p:nvCxnSpPr>
+        <p:spPr>
+          <a:xfrm>
+            <a:off x="6447934" y="2780907"/>
+            <a:ext cx="0" cy="735291"/>
+          </a:xfrm>
+          <a:prstGeom prst="straightConnector1">
+            <a:avLst/>
+          </a:prstGeom>
+          <a:ln w="44450">
+            <a:tailEnd type="triangle"/>
+          </a:ln>
+        </p:spPr>
+        <p:style>
+          <a:lnRef idx="2">
+            <a:schemeClr val="accent4"/>
+          </a:lnRef>
+          <a:fillRef idx="0">
+            <a:schemeClr val="accent4"/>
+          </a:fillRef>
+          <a:effectRef idx="1">
+            <a:schemeClr val="accent4"/>
+          </a:effectRef>
+          <a:fontRef idx="minor">
+            <a:schemeClr val="tx1"/>
+          </a:fontRef>
+        </p:style>
+      </p:cxnSp>
+      <p:cxnSp>
+        <p:nvCxnSpPr>
+          <p:cNvPr id="15" name="Straight Arrow Connector 14">
+            <a:extLst>
+              <a:ext uri="{FF2B5EF4-FFF2-40B4-BE49-F238E27FC236}">
+                <a16:creationId xmlns:a16="http://schemas.microsoft.com/office/drawing/2014/main" id="{4DFD7408-EB97-E952-FDB1-8AC073B7E2AE}"/>
+              </a:ext>
+            </a:extLst>
+          </p:cNvPr>
+          <p:cNvCxnSpPr>
+            <a:cxnSpLocks/>
+          </p:cNvCxnSpPr>
+          <p:nvPr/>
+        </p:nvCxnSpPr>
+        <p:spPr>
+          <a:xfrm flipV="1">
+            <a:off x="6447934" y="3704734"/>
+            <a:ext cx="0" cy="515741"/>
+          </a:xfrm>
+          <a:prstGeom prst="straightConnector1">
+            <a:avLst/>
+          </a:prstGeom>
+          <a:ln w="44450">
+            <a:tailEnd type="triangle"/>
+          </a:ln>
+        </p:spPr>
+        <p:style>
+          <a:lnRef idx="2">
+            <a:schemeClr val="accent4"/>
+          </a:lnRef>
+          <a:fillRef idx="0">
+            <a:schemeClr val="accent4"/>
+          </a:fillRef>
+          <a:effectRef idx="1">
+            <a:schemeClr val="accent4"/>
+          </a:effectRef>
+          <a:fontRef idx="minor">
+            <a:schemeClr val="tx1"/>
+          </a:fontRef>
+        </p:style>
+      </p:cxnSp>
+      <p:sp>
+        <p:nvSpPr>
+          <p:cNvPr id="18" name="TextBox 17">
+            <a:extLst>
+              <a:ext uri="{FF2B5EF4-FFF2-40B4-BE49-F238E27FC236}">
+                <a16:creationId xmlns:a16="http://schemas.microsoft.com/office/drawing/2014/main" id="{58EAC0F8-4D06-BDCA-9AE1-255681F59466}"/>
+              </a:ext>
+            </a:extLst>
+          </p:cNvPr>
+          <p:cNvSpPr txBox="1"/>
+          <p:nvPr/>
+        </p:nvSpPr>
+        <p:spPr>
+          <a:xfrm>
+            <a:off x="6023779" y="4208315"/>
+            <a:ext cx="848309" cy="369332"/>
+          </a:xfrm>
+          <a:prstGeom prst="rect">
+            <a:avLst/>
+          </a:prstGeom>
+          <a:noFill/>
+        </p:spPr>
+        <p:txBody>
+          <a:bodyPr wrap="none" rtlCol="0">
+            <a:spAutoFit/>
+          </a:bodyPr>
+          <a:lstStyle/>
+          <a:p>
+            <a:r>
+              <a:rPr lang="en-US" dirty="0"/>
+              <a:t>0.016”</a:t>
+            </a:r>
+          </a:p>
+        </p:txBody>
+      </p:sp>
+      <p:cxnSp>
+        <p:nvCxnSpPr>
+          <p:cNvPr id="20" name="Straight Arrow Connector 19">
+            <a:extLst>
+              <a:ext uri="{FF2B5EF4-FFF2-40B4-BE49-F238E27FC236}">
+                <a16:creationId xmlns:a16="http://schemas.microsoft.com/office/drawing/2014/main" id="{F7D240DE-A4C4-9283-DFB4-E7D05815A24B}"/>
+              </a:ext>
+            </a:extLst>
+          </p:cNvPr>
+          <p:cNvCxnSpPr>
+            <a:cxnSpLocks/>
+          </p:cNvCxnSpPr>
+          <p:nvPr/>
+        </p:nvCxnSpPr>
+        <p:spPr>
+          <a:xfrm>
+            <a:off x="6096000" y="697584"/>
+            <a:ext cx="0" cy="2592371"/>
+          </a:xfrm>
+          <a:prstGeom prst="straightConnector1">
+            <a:avLst/>
+          </a:prstGeom>
+          <a:ln w="44450">
+            <a:tailEnd type="triangle"/>
+          </a:ln>
+        </p:spPr>
+        <p:style>
+          <a:lnRef idx="2">
+            <a:schemeClr val="accent4"/>
+          </a:lnRef>
+          <a:fillRef idx="0">
+            <a:schemeClr val="accent4"/>
+          </a:fillRef>
+          <a:effectRef idx="1">
+            <a:schemeClr val="accent4"/>
+          </a:effectRef>
+          <a:fontRef idx="minor">
+            <a:schemeClr val="tx1"/>
+          </a:fontRef>
+        </p:style>
+      </p:cxnSp>
+      <p:sp>
+        <p:nvSpPr>
+          <p:cNvPr id="22" name="TextBox 21">
+            <a:extLst>
+              <a:ext uri="{FF2B5EF4-FFF2-40B4-BE49-F238E27FC236}">
+                <a16:creationId xmlns:a16="http://schemas.microsoft.com/office/drawing/2014/main" id="{7A41AD1E-5C5C-C55C-DEAE-C876DF9F8169}"/>
+              </a:ext>
+            </a:extLst>
+          </p:cNvPr>
+          <p:cNvSpPr txBox="1"/>
+          <p:nvPr/>
+        </p:nvSpPr>
+        <p:spPr>
+          <a:xfrm>
+            <a:off x="5778392" y="328252"/>
+            <a:ext cx="1164101" cy="369332"/>
+          </a:xfrm>
+          <a:prstGeom prst="rect">
+            <a:avLst/>
+          </a:prstGeom>
+          <a:noFill/>
+        </p:spPr>
+        <p:txBody>
+          <a:bodyPr wrap="none" rtlCol="0">
+            <a:spAutoFit/>
+          </a:bodyPr>
+          <a:lstStyle/>
+          <a:p>
+            <a:r>
+              <a:rPr lang="en-US" dirty="0"/>
+              <a:t>24X65 mil</a:t>
+            </a:r>
+          </a:p>
+        </p:txBody>
+      </p:sp>
+      <p:cxnSp>
+        <p:nvCxnSpPr>
+          <p:cNvPr id="23" name="Straight Arrow Connector 22">
+            <a:extLst>
+              <a:ext uri="{FF2B5EF4-FFF2-40B4-BE49-F238E27FC236}">
+                <a16:creationId xmlns:a16="http://schemas.microsoft.com/office/drawing/2014/main" id="{D0A48164-88FF-5D70-8A4B-8F8B8FCD679A}"/>
+              </a:ext>
+            </a:extLst>
+          </p:cNvPr>
+          <p:cNvCxnSpPr>
+            <a:cxnSpLocks/>
+          </p:cNvCxnSpPr>
+          <p:nvPr/>
+        </p:nvCxnSpPr>
+        <p:spPr>
+          <a:xfrm>
+            <a:off x="5014821" y="3392603"/>
+            <a:ext cx="659876" cy="0"/>
+          </a:xfrm>
+          <a:prstGeom prst="straightConnector1">
+            <a:avLst/>
+          </a:prstGeom>
+          <a:ln w="44450">
+            <a:tailEnd type="triangle"/>
+          </a:ln>
+        </p:spPr>
+        <p:style>
+          <a:lnRef idx="2">
+            <a:schemeClr val="accent4"/>
+          </a:lnRef>
+          <a:fillRef idx="0">
+            <a:schemeClr val="accent4"/>
+          </a:fillRef>
+          <a:effectRef idx="1">
+            <a:schemeClr val="accent4"/>
+          </a:effectRef>
+          <a:fontRef idx="minor">
+            <a:schemeClr val="tx1"/>
+          </a:fontRef>
+        </p:style>
+      </p:cxnSp>
+      <p:cxnSp>
+        <p:nvCxnSpPr>
+          <p:cNvPr id="25" name="Straight Arrow Connector 24">
+            <a:extLst>
+              <a:ext uri="{FF2B5EF4-FFF2-40B4-BE49-F238E27FC236}">
+                <a16:creationId xmlns:a16="http://schemas.microsoft.com/office/drawing/2014/main" id="{7565EC85-B174-7DD3-5795-AB590DA90862}"/>
+              </a:ext>
+            </a:extLst>
+          </p:cNvPr>
+          <p:cNvCxnSpPr>
+            <a:cxnSpLocks/>
+          </p:cNvCxnSpPr>
+          <p:nvPr/>
+        </p:nvCxnSpPr>
+        <p:spPr>
+          <a:xfrm flipH="1">
+            <a:off x="6834380" y="3392603"/>
+            <a:ext cx="697822" cy="0"/>
+          </a:xfrm>
+          <a:prstGeom prst="straightConnector1">
+            <a:avLst/>
+          </a:prstGeom>
+          <a:ln w="44450">
+            <a:tailEnd type="triangle"/>
+          </a:ln>
+        </p:spPr>
+        <p:style>
+          <a:lnRef idx="2">
+            <a:schemeClr val="accent4"/>
+          </a:lnRef>
+          <a:fillRef idx="0">
+            <a:schemeClr val="accent4"/>
+          </a:fillRef>
+          <a:effectRef idx="1">
+            <a:schemeClr val="accent4"/>
+          </a:effectRef>
+          <a:fontRef idx="minor">
+            <a:schemeClr val="tx1"/>
+          </a:fontRef>
+        </p:style>
+      </p:cxnSp>
+      <p:sp>
+        <p:nvSpPr>
+          <p:cNvPr id="27" name="TextBox 26">
+            <a:extLst>
+              <a:ext uri="{FF2B5EF4-FFF2-40B4-BE49-F238E27FC236}">
+                <a16:creationId xmlns:a16="http://schemas.microsoft.com/office/drawing/2014/main" id="{3E4DE735-19A5-4964-07EA-B0EBACAA80EA}"/>
+              </a:ext>
+            </a:extLst>
+          </p:cNvPr>
+          <p:cNvSpPr txBox="1"/>
+          <p:nvPr/>
+        </p:nvSpPr>
+        <p:spPr>
+          <a:xfrm>
+            <a:off x="7543134" y="3207937"/>
+            <a:ext cx="848309" cy="369332"/>
+          </a:xfrm>
+          <a:prstGeom prst="rect">
+            <a:avLst/>
+          </a:prstGeom>
+          <a:noFill/>
+        </p:spPr>
+        <p:txBody>
+          <a:bodyPr wrap="none" rtlCol="0">
+            <a:spAutoFit/>
+          </a:bodyPr>
+          <a:lstStyle/>
+          <a:p>
+            <a:r>
+              <a:rPr lang="en-US" dirty="0"/>
+              <a:t>0.085”</a:t>
+            </a:r>
+          </a:p>
+        </p:txBody>
+      </p:sp>
+    </p:spTree>
+    <p:extLst>
+      <p:ext uri="{BB962C8B-B14F-4D97-AF65-F5344CB8AC3E}">
+        <p14:creationId xmlns:p14="http://schemas.microsoft.com/office/powerpoint/2010/main" val="1433056603"/>
+      </p:ext>
+    </p:extLst>
+  </p:cSld>
+  <p:clrMapOvr>
+    <a:masterClrMapping/>
+  </p:clrMapOvr>
+</p:sld>
+</file>
+
+<file path=ppt/slides/slide23.xml><?xml version="1.0" encoding="utf-8"?>
+<p:sld xmlns:a="http://schemas.openxmlformats.org/drawingml/2006/main" xmlns:r="http://schemas.openxmlformats.org/officeDocument/2006/relationships" xmlns:p="http://schemas.openxmlformats.org/presentationml/2006/main">
+  <p:cSld>
+    <p:spTree>
+      <p:nvGrpSpPr>
+        <p:cNvPr id="1" name=""/>
+        <p:cNvGrpSpPr/>
+        <p:nvPr/>
+      </p:nvGrpSpPr>
+      <p:grpSpPr>
+        <a:xfrm>
+          <a:off x="0" y="0"/>
+          <a:ext cx="0" cy="0"/>
+          <a:chOff x="0" y="0"/>
+          <a:chExt cx="0" cy="0"/>
+        </a:xfrm>
+      </p:grpSpPr>
+      <p:pic>
+        <p:nvPicPr>
+          <p:cNvPr id="5" name="Picture 4">
+            <a:extLst>
+              <a:ext uri="{FF2B5EF4-FFF2-40B4-BE49-F238E27FC236}">
+                <a16:creationId xmlns:a16="http://schemas.microsoft.com/office/drawing/2014/main" id="{50C5FCEF-3F3E-5DA5-B037-27BCAA483881}"/>
+              </a:ext>
+            </a:extLst>
+          </p:cNvPr>
+          <p:cNvPicPr>
+            <a:picLocks noChangeAspect="1"/>
+          </p:cNvPicPr>
+          <p:nvPr/>
+        </p:nvPicPr>
+        <p:blipFill>
+          <a:blip r:embed="rId2"/>
+          <a:stretch>
+            <a:fillRect/>
+          </a:stretch>
+        </p:blipFill>
+        <p:spPr>
+          <a:xfrm>
+            <a:off x="447170" y="1766535"/>
+            <a:ext cx="3076064" cy="3063593"/>
+          </a:xfrm>
+          <a:prstGeom prst="rect">
+            <a:avLst/>
+          </a:prstGeom>
+        </p:spPr>
+      </p:pic>
+      <p:pic>
+        <p:nvPicPr>
+          <p:cNvPr id="7" name="Picture 6">
+            <a:extLst>
+              <a:ext uri="{FF2B5EF4-FFF2-40B4-BE49-F238E27FC236}">
+                <a16:creationId xmlns:a16="http://schemas.microsoft.com/office/drawing/2014/main" id="{F3990280-9F48-B0CB-83A0-5175C568EBD2}"/>
+              </a:ext>
+            </a:extLst>
+          </p:cNvPr>
+          <p:cNvPicPr>
+            <a:picLocks noChangeAspect="1"/>
+          </p:cNvPicPr>
+          <p:nvPr/>
+        </p:nvPicPr>
+        <p:blipFill>
+          <a:blip r:embed="rId3"/>
+          <a:stretch>
+            <a:fillRect/>
+          </a:stretch>
+        </p:blipFill>
+        <p:spPr>
+          <a:xfrm>
+            <a:off x="7749648" y="1673829"/>
+            <a:ext cx="3918350" cy="3113061"/>
+          </a:xfrm>
+          <a:prstGeom prst="rect">
+            <a:avLst/>
+          </a:prstGeom>
+        </p:spPr>
+      </p:pic>
+      <p:pic>
+        <p:nvPicPr>
+          <p:cNvPr id="9" name="Picture 8">
+            <a:extLst>
+              <a:ext uri="{FF2B5EF4-FFF2-40B4-BE49-F238E27FC236}">
+                <a16:creationId xmlns:a16="http://schemas.microsoft.com/office/drawing/2014/main" id="{873A5807-349C-F05D-3B2A-B21EBC2ABE77}"/>
+              </a:ext>
+            </a:extLst>
+          </p:cNvPr>
+          <p:cNvPicPr>
+            <a:picLocks noChangeAspect="1"/>
+          </p:cNvPicPr>
+          <p:nvPr/>
+        </p:nvPicPr>
+        <p:blipFill>
+          <a:blip r:embed="rId4"/>
+          <a:stretch>
+            <a:fillRect/>
+          </a:stretch>
+        </p:blipFill>
+        <p:spPr>
+          <a:xfrm>
+            <a:off x="3523234" y="1630592"/>
+            <a:ext cx="4226414" cy="3199536"/>
+          </a:xfrm>
+          <a:prstGeom prst="rect">
+            <a:avLst/>
+          </a:prstGeom>
+        </p:spPr>
+      </p:pic>
+      <p:cxnSp>
+        <p:nvCxnSpPr>
+          <p:cNvPr id="10" name="Straight Arrow Connector 9">
+            <a:extLst>
+              <a:ext uri="{FF2B5EF4-FFF2-40B4-BE49-F238E27FC236}">
+                <a16:creationId xmlns:a16="http://schemas.microsoft.com/office/drawing/2014/main" id="{50300834-6915-C9C9-ADAE-A960716EDF12}"/>
+              </a:ext>
+            </a:extLst>
+          </p:cNvPr>
+          <p:cNvCxnSpPr/>
+          <p:nvPr/>
+        </p:nvCxnSpPr>
+        <p:spPr>
+          <a:xfrm>
+            <a:off x="10558021" y="2337847"/>
+            <a:ext cx="0" cy="735291"/>
+          </a:xfrm>
+          <a:prstGeom prst="straightConnector1">
+            <a:avLst/>
+          </a:prstGeom>
+          <a:ln w="44450">
+            <a:solidFill>
+              <a:srgbClr val="FF0000"/>
+            </a:solidFill>
+            <a:tailEnd type="triangle"/>
+          </a:ln>
+        </p:spPr>
+        <p:style>
+          <a:lnRef idx="2">
+            <a:schemeClr val="accent4"/>
+          </a:lnRef>
+          <a:fillRef idx="0">
+            <a:schemeClr val="accent4"/>
+          </a:fillRef>
+          <a:effectRef idx="1">
+            <a:schemeClr val="accent4"/>
+          </a:effectRef>
+          <a:fontRef idx="minor">
+            <a:schemeClr val="tx1"/>
+          </a:fontRef>
+        </p:style>
+      </p:cxnSp>
+      <p:cxnSp>
+        <p:nvCxnSpPr>
+          <p:cNvPr id="11" name="Straight Arrow Connector 10">
+            <a:extLst>
+              <a:ext uri="{FF2B5EF4-FFF2-40B4-BE49-F238E27FC236}">
+                <a16:creationId xmlns:a16="http://schemas.microsoft.com/office/drawing/2014/main" id="{97B22942-018B-8814-544D-2D0F23F6F6D1}"/>
+              </a:ext>
+            </a:extLst>
+          </p:cNvPr>
+          <p:cNvCxnSpPr>
+            <a:cxnSpLocks/>
+          </p:cNvCxnSpPr>
+          <p:nvPr/>
+        </p:nvCxnSpPr>
+        <p:spPr>
+          <a:xfrm flipV="1">
+            <a:off x="10558021" y="3608110"/>
+            <a:ext cx="0" cy="520831"/>
+          </a:xfrm>
+          <a:prstGeom prst="straightConnector1">
+            <a:avLst/>
+          </a:prstGeom>
+          <a:ln w="44450">
+            <a:solidFill>
+              <a:srgbClr val="FF0000"/>
+            </a:solidFill>
+            <a:tailEnd type="triangle"/>
+          </a:ln>
+        </p:spPr>
+        <p:style>
+          <a:lnRef idx="2">
+            <a:schemeClr val="accent4"/>
+          </a:lnRef>
+          <a:fillRef idx="0">
+            <a:schemeClr val="accent4"/>
+          </a:fillRef>
+          <a:effectRef idx="1">
+            <a:schemeClr val="accent4"/>
+          </a:effectRef>
+          <a:fontRef idx="minor">
+            <a:schemeClr val="tx1"/>
+          </a:fontRef>
+        </p:style>
+      </p:cxnSp>
+      <p:sp>
+        <p:nvSpPr>
+          <p:cNvPr id="13" name="TextBox 12">
+            <a:extLst>
+              <a:ext uri="{FF2B5EF4-FFF2-40B4-BE49-F238E27FC236}">
+                <a16:creationId xmlns:a16="http://schemas.microsoft.com/office/drawing/2014/main" id="{FF6C5123-45FF-CBBD-575D-FFA96E13B8EC}"/>
+              </a:ext>
+            </a:extLst>
+          </p:cNvPr>
+          <p:cNvSpPr txBox="1"/>
+          <p:nvPr/>
+        </p:nvSpPr>
+        <p:spPr>
+          <a:xfrm>
+            <a:off x="10133866" y="4088583"/>
+            <a:ext cx="848309" cy="369332"/>
+          </a:xfrm>
+          <a:prstGeom prst="rect">
+            <a:avLst/>
+          </a:prstGeom>
+          <a:noFill/>
+        </p:spPr>
+        <p:txBody>
+          <a:bodyPr wrap="none" rtlCol="0">
+            <a:spAutoFit/>
+          </a:bodyPr>
+          <a:lstStyle/>
+          <a:p>
+            <a:r>
+              <a:rPr lang="en-US" dirty="0"/>
+              <a:t>0.044”</a:t>
+            </a:r>
+          </a:p>
+        </p:txBody>
+      </p:sp>
+      <p:cxnSp>
+        <p:nvCxnSpPr>
+          <p:cNvPr id="14" name="Straight Arrow Connector 13">
+            <a:extLst>
+              <a:ext uri="{FF2B5EF4-FFF2-40B4-BE49-F238E27FC236}">
+                <a16:creationId xmlns:a16="http://schemas.microsoft.com/office/drawing/2014/main" id="{C9ABFF5E-B1F2-57E6-60A5-EE3BC78F307E}"/>
+              </a:ext>
+            </a:extLst>
+          </p:cNvPr>
+          <p:cNvCxnSpPr>
+            <a:cxnSpLocks/>
+          </p:cNvCxnSpPr>
+          <p:nvPr/>
+        </p:nvCxnSpPr>
+        <p:spPr>
+          <a:xfrm>
+            <a:off x="9133788" y="3379508"/>
+            <a:ext cx="772998" cy="0"/>
+          </a:xfrm>
+          <a:prstGeom prst="straightConnector1">
+            <a:avLst/>
+          </a:prstGeom>
+          <a:ln w="44450">
+            <a:solidFill>
+              <a:srgbClr val="FF0000"/>
+            </a:solidFill>
+            <a:tailEnd type="triangle"/>
+          </a:ln>
+        </p:spPr>
+        <p:style>
+          <a:lnRef idx="2">
+            <a:schemeClr val="accent4"/>
+          </a:lnRef>
+          <a:fillRef idx="0">
+            <a:schemeClr val="accent4"/>
+          </a:fillRef>
+          <a:effectRef idx="1">
+            <a:schemeClr val="accent4"/>
+          </a:effectRef>
+          <a:fontRef idx="minor">
+            <a:schemeClr val="tx1"/>
+          </a:fontRef>
+        </p:style>
+      </p:cxnSp>
+      <p:cxnSp>
+        <p:nvCxnSpPr>
+          <p:cNvPr id="16" name="Straight Arrow Connector 15">
+            <a:extLst>
+              <a:ext uri="{FF2B5EF4-FFF2-40B4-BE49-F238E27FC236}">
+                <a16:creationId xmlns:a16="http://schemas.microsoft.com/office/drawing/2014/main" id="{45634916-98E0-15C9-2A1B-14073795E615}"/>
+              </a:ext>
+            </a:extLst>
+          </p:cNvPr>
+          <p:cNvCxnSpPr>
+            <a:cxnSpLocks/>
+          </p:cNvCxnSpPr>
+          <p:nvPr/>
+        </p:nvCxnSpPr>
+        <p:spPr>
+          <a:xfrm flipH="1">
+            <a:off x="11133056" y="3379508"/>
+            <a:ext cx="301658" cy="0"/>
+          </a:xfrm>
+          <a:prstGeom prst="straightConnector1">
+            <a:avLst/>
+          </a:prstGeom>
+          <a:ln w="44450">
+            <a:solidFill>
+              <a:srgbClr val="FF0000"/>
+            </a:solidFill>
+            <a:tailEnd type="triangle"/>
+          </a:ln>
+        </p:spPr>
+        <p:style>
+          <a:lnRef idx="2">
+            <a:schemeClr val="accent4"/>
+          </a:lnRef>
+          <a:fillRef idx="0">
+            <a:schemeClr val="accent4"/>
+          </a:fillRef>
+          <a:effectRef idx="1">
+            <a:schemeClr val="accent4"/>
+          </a:effectRef>
+          <a:fontRef idx="minor">
+            <a:schemeClr val="tx1"/>
+          </a:fontRef>
+        </p:style>
+      </p:cxnSp>
+      <p:sp>
+        <p:nvSpPr>
+          <p:cNvPr id="18" name="TextBox 17">
+            <a:extLst>
+              <a:ext uri="{FF2B5EF4-FFF2-40B4-BE49-F238E27FC236}">
+                <a16:creationId xmlns:a16="http://schemas.microsoft.com/office/drawing/2014/main" id="{6B9FE6A7-4D47-1FD9-07C8-A806CE2613B4}"/>
+              </a:ext>
+            </a:extLst>
+          </p:cNvPr>
+          <p:cNvSpPr txBox="1"/>
+          <p:nvPr/>
+        </p:nvSpPr>
+        <p:spPr>
+          <a:xfrm>
+            <a:off x="11031765" y="3421489"/>
+            <a:ext cx="848309" cy="369332"/>
+          </a:xfrm>
+          <a:prstGeom prst="rect">
+            <a:avLst/>
+          </a:prstGeom>
+          <a:noFill/>
+        </p:spPr>
+        <p:txBody>
+          <a:bodyPr wrap="none" rtlCol="0">
+            <a:spAutoFit/>
+          </a:bodyPr>
+          <a:lstStyle/>
+          <a:p>
+            <a:r>
+              <a:rPr lang="en-US" dirty="0"/>
+              <a:t>0.103”</a:t>
+            </a:r>
+          </a:p>
+        </p:txBody>
+      </p:sp>
+    </p:spTree>
+    <p:extLst>
+      <p:ext uri="{BB962C8B-B14F-4D97-AF65-F5344CB8AC3E}">
+        <p14:creationId xmlns:p14="http://schemas.microsoft.com/office/powerpoint/2010/main" val="3745314826"/>
       </p:ext>
     </p:extLst>
   </p:cSld>

</xml_diff>

<commit_message>
added jaws design, tweaked mechanical for M2.5 screws
</commit_message>
<xml_diff>
--- a/SP3T-ECAL.pptx
+++ b/SP3T-ECAL.pptx
@@ -28,6 +28,8 @@
     <p:sldId id="276" r:id="rId22"/>
     <p:sldId id="277" r:id="rId23"/>
     <p:sldId id="278" r:id="rId24"/>
+    <p:sldId id="279" r:id="rId25"/>
+    <p:sldId id="280" r:id="rId26"/>
   </p:sldIdLst>
   <p:sldSz cx="12192000" cy="6858000"/>
   <p:notesSz cx="7023100" cy="9309100"/>
@@ -281,7 +283,7 @@
           <a:p>
             <a:fld id="{7053F05D-9385-4B1A-9374-4A2BEAD69DDD}" type="datetimeFigureOut">
               <a:rPr lang="en-US" smtClean="0"/>
-              <a:t>3/9/2026</a:t>
+              <a:t>3/10/2026</a:t>
             </a:fld>
             <a:endParaRPr lang="en-US"/>
           </a:p>
@@ -479,7 +481,7 @@
           <a:p>
             <a:fld id="{7053F05D-9385-4B1A-9374-4A2BEAD69DDD}" type="datetimeFigureOut">
               <a:rPr lang="en-US" smtClean="0"/>
-              <a:t>3/9/2026</a:t>
+              <a:t>3/10/2026</a:t>
             </a:fld>
             <a:endParaRPr lang="en-US"/>
           </a:p>
@@ -687,7 +689,7 @@
           <a:p>
             <a:fld id="{7053F05D-9385-4B1A-9374-4A2BEAD69DDD}" type="datetimeFigureOut">
               <a:rPr lang="en-US" smtClean="0"/>
-              <a:t>3/9/2026</a:t>
+              <a:t>3/10/2026</a:t>
             </a:fld>
             <a:endParaRPr lang="en-US"/>
           </a:p>
@@ -885,7 +887,7 @@
           <a:p>
             <a:fld id="{7053F05D-9385-4B1A-9374-4A2BEAD69DDD}" type="datetimeFigureOut">
               <a:rPr lang="en-US" smtClean="0"/>
-              <a:t>3/9/2026</a:t>
+              <a:t>3/10/2026</a:t>
             </a:fld>
             <a:endParaRPr lang="en-US"/>
           </a:p>
@@ -1160,7 +1162,7 @@
           <a:p>
             <a:fld id="{7053F05D-9385-4B1A-9374-4A2BEAD69DDD}" type="datetimeFigureOut">
               <a:rPr lang="en-US" smtClean="0"/>
-              <a:t>3/9/2026</a:t>
+              <a:t>3/10/2026</a:t>
             </a:fld>
             <a:endParaRPr lang="en-US"/>
           </a:p>
@@ -1425,7 +1427,7 @@
           <a:p>
             <a:fld id="{7053F05D-9385-4B1A-9374-4A2BEAD69DDD}" type="datetimeFigureOut">
               <a:rPr lang="en-US" smtClean="0"/>
-              <a:t>3/9/2026</a:t>
+              <a:t>3/10/2026</a:t>
             </a:fld>
             <a:endParaRPr lang="en-US"/>
           </a:p>
@@ -1837,7 +1839,7 @@
           <a:p>
             <a:fld id="{7053F05D-9385-4B1A-9374-4A2BEAD69DDD}" type="datetimeFigureOut">
               <a:rPr lang="en-US" smtClean="0"/>
-              <a:t>3/9/2026</a:t>
+              <a:t>3/10/2026</a:t>
             </a:fld>
             <a:endParaRPr lang="en-US"/>
           </a:p>
@@ -1978,7 +1980,7 @@
           <a:p>
             <a:fld id="{7053F05D-9385-4B1A-9374-4A2BEAD69DDD}" type="datetimeFigureOut">
               <a:rPr lang="en-US" smtClean="0"/>
-              <a:t>3/9/2026</a:t>
+              <a:t>3/10/2026</a:t>
             </a:fld>
             <a:endParaRPr lang="en-US"/>
           </a:p>
@@ -2091,7 +2093,7 @@
           <a:p>
             <a:fld id="{7053F05D-9385-4B1A-9374-4A2BEAD69DDD}" type="datetimeFigureOut">
               <a:rPr lang="en-US" smtClean="0"/>
-              <a:t>3/9/2026</a:t>
+              <a:t>3/10/2026</a:t>
             </a:fld>
             <a:endParaRPr lang="en-US"/>
           </a:p>
@@ -2402,7 +2404,7 @@
           <a:p>
             <a:fld id="{7053F05D-9385-4B1A-9374-4A2BEAD69DDD}" type="datetimeFigureOut">
               <a:rPr lang="en-US" smtClean="0"/>
-              <a:t>3/9/2026</a:t>
+              <a:t>3/10/2026</a:t>
             </a:fld>
             <a:endParaRPr lang="en-US"/>
           </a:p>
@@ -2690,7 +2692,7 @@
           <a:p>
             <a:fld id="{7053F05D-9385-4B1A-9374-4A2BEAD69DDD}" type="datetimeFigureOut">
               <a:rPr lang="en-US" smtClean="0"/>
-              <a:t>3/9/2026</a:t>
+              <a:t>3/10/2026</a:t>
             </a:fld>
             <a:endParaRPr lang="en-US"/>
           </a:p>
@@ -2931,7 +2933,7 @@
           <a:p>
             <a:fld id="{7053F05D-9385-4B1A-9374-4A2BEAD69DDD}" type="datetimeFigureOut">
               <a:rPr lang="en-US" smtClean="0"/>
-              <a:t>3/9/2026</a:t>
+              <a:t>3/10/2026</a:t>
             </a:fld>
             <a:endParaRPr lang="en-US"/>
           </a:p>
@@ -7400,6 +7402,561 @@
     <p:extLst>
       <p:ext uri="{BB962C8B-B14F-4D97-AF65-F5344CB8AC3E}">
         <p14:creationId xmlns:p14="http://schemas.microsoft.com/office/powerpoint/2010/main" val="3745314826"/>
+      </p:ext>
+    </p:extLst>
+  </p:cSld>
+  <p:clrMapOvr>
+    <a:masterClrMapping/>
+  </p:clrMapOvr>
+</p:sld>
+</file>
+
+<file path=ppt/slides/slide24.xml><?xml version="1.0" encoding="utf-8"?>
+<p:sld xmlns:a="http://schemas.openxmlformats.org/drawingml/2006/main" xmlns:r="http://schemas.openxmlformats.org/officeDocument/2006/relationships" xmlns:p="http://schemas.openxmlformats.org/presentationml/2006/main">
+  <p:cSld>
+    <p:spTree>
+      <p:nvGrpSpPr>
+        <p:cNvPr id="1" name=""/>
+        <p:cNvGrpSpPr/>
+        <p:nvPr/>
+      </p:nvGrpSpPr>
+      <p:grpSpPr>
+        <a:xfrm>
+          <a:off x="0" y="0"/>
+          <a:ext cx="0" cy="0"/>
+          <a:chOff x="0" y="0"/>
+          <a:chExt cx="0" cy="0"/>
+        </a:xfrm>
+      </p:grpSpPr>
+      <p:sp>
+        <p:nvSpPr>
+          <p:cNvPr id="2" name="Title 1">
+            <a:extLst>
+              <a:ext uri="{FF2B5EF4-FFF2-40B4-BE49-F238E27FC236}">
+                <a16:creationId xmlns:a16="http://schemas.microsoft.com/office/drawing/2014/main" id="{C3471BF4-A721-08DA-8FB6-6B6790DAFA7C}"/>
+              </a:ext>
+            </a:extLst>
+          </p:cNvPr>
+          <p:cNvSpPr>
+            <a:spLocks noGrp="1"/>
+          </p:cNvSpPr>
+          <p:nvPr>
+            <p:ph type="title"/>
+          </p:nvPr>
+        </p:nvSpPr>
+        <p:spPr/>
+        <p:txBody>
+          <a:bodyPr/>
+          <a:lstStyle/>
+          <a:p>
+            <a:r>
+              <a:rPr lang="en-US" dirty="0"/>
+              <a:t>Looking at JAWS designs and </a:t>
+            </a:r>
+            <a:r>
+              <a:rPr lang="en-US" dirty="0" err="1"/>
+              <a:t>Aivon</a:t>
+            </a:r>
+            <a:r>
+              <a:rPr lang="en-US" dirty="0"/>
+              <a:t> designs</a:t>
+            </a:r>
+          </a:p>
+        </p:txBody>
+      </p:sp>
+      <p:pic>
+        <p:nvPicPr>
+          <p:cNvPr id="5" name="Picture 4">
+            <a:extLst>
+              <a:ext uri="{FF2B5EF4-FFF2-40B4-BE49-F238E27FC236}">
+                <a16:creationId xmlns:a16="http://schemas.microsoft.com/office/drawing/2014/main" id="{07DEF9D9-B98C-458C-E675-467D0A3079A8}"/>
+              </a:ext>
+            </a:extLst>
+          </p:cNvPr>
+          <p:cNvPicPr>
+            <a:picLocks noChangeAspect="1"/>
+          </p:cNvPicPr>
+          <p:nvPr/>
+        </p:nvPicPr>
+        <p:blipFill>
+          <a:blip r:embed="rId2"/>
+          <a:stretch>
+            <a:fillRect/>
+          </a:stretch>
+        </p:blipFill>
+        <p:spPr>
+          <a:xfrm>
+            <a:off x="923362" y="1301142"/>
+            <a:ext cx="4977516" cy="2068780"/>
+          </a:xfrm>
+          <a:prstGeom prst="rect">
+            <a:avLst/>
+          </a:prstGeom>
+        </p:spPr>
+      </p:pic>
+      <p:pic>
+        <p:nvPicPr>
+          <p:cNvPr id="7" name="Picture 6">
+            <a:extLst>
+              <a:ext uri="{FF2B5EF4-FFF2-40B4-BE49-F238E27FC236}">
+                <a16:creationId xmlns:a16="http://schemas.microsoft.com/office/drawing/2014/main" id="{3AB93486-4CD2-11A6-703D-3859914A7A7C}"/>
+              </a:ext>
+            </a:extLst>
+          </p:cNvPr>
+          <p:cNvPicPr>
+            <a:picLocks noChangeAspect="1"/>
+          </p:cNvPicPr>
+          <p:nvPr/>
+        </p:nvPicPr>
+        <p:blipFill>
+          <a:blip r:embed="rId3"/>
+          <a:stretch>
+            <a:fillRect/>
+          </a:stretch>
+        </p:blipFill>
+        <p:spPr>
+          <a:xfrm>
+            <a:off x="7549054" y="1690688"/>
+            <a:ext cx="3719584" cy="3215345"/>
+          </a:xfrm>
+          <a:prstGeom prst="rect">
+            <a:avLst/>
+          </a:prstGeom>
+        </p:spPr>
+      </p:pic>
+      <p:pic>
+        <p:nvPicPr>
+          <p:cNvPr id="9" name="Picture 8">
+            <a:extLst>
+              <a:ext uri="{FF2B5EF4-FFF2-40B4-BE49-F238E27FC236}">
+                <a16:creationId xmlns:a16="http://schemas.microsoft.com/office/drawing/2014/main" id="{0CFA5B75-F913-F9CF-ACB7-737ACC73F66A}"/>
+              </a:ext>
+            </a:extLst>
+          </p:cNvPr>
+          <p:cNvPicPr>
+            <a:picLocks noChangeAspect="1"/>
+          </p:cNvPicPr>
+          <p:nvPr/>
+        </p:nvPicPr>
+        <p:blipFill>
+          <a:blip r:embed="rId4"/>
+          <a:stretch>
+            <a:fillRect/>
+          </a:stretch>
+        </p:blipFill>
+        <p:spPr>
+          <a:xfrm>
+            <a:off x="333955" y="3669014"/>
+            <a:ext cx="3979575" cy="2996596"/>
+          </a:xfrm>
+          <a:prstGeom prst="rect">
+            <a:avLst/>
+          </a:prstGeom>
+        </p:spPr>
+      </p:pic>
+      <p:sp>
+        <p:nvSpPr>
+          <p:cNvPr id="10" name="TextBox 9">
+            <a:extLst>
+              <a:ext uri="{FF2B5EF4-FFF2-40B4-BE49-F238E27FC236}">
+                <a16:creationId xmlns:a16="http://schemas.microsoft.com/office/drawing/2014/main" id="{EA8728A0-B058-A031-D309-DDDCD7AB580F}"/>
+              </a:ext>
+            </a:extLst>
+          </p:cNvPr>
+          <p:cNvSpPr txBox="1"/>
+          <p:nvPr/>
+        </p:nvSpPr>
+        <p:spPr>
+          <a:xfrm>
+            <a:off x="4733229" y="4170941"/>
+            <a:ext cx="2456954" cy="1200329"/>
+          </a:xfrm>
+          <a:prstGeom prst="rect">
+            <a:avLst/>
+          </a:prstGeom>
+          <a:noFill/>
+        </p:spPr>
+        <p:txBody>
+          <a:bodyPr wrap="square" rtlCol="0">
+            <a:spAutoFit/>
+          </a:bodyPr>
+          <a:lstStyle/>
+          <a:p>
+            <a:r>
+              <a:rPr lang="en-US" dirty="0"/>
+              <a:t>Move to 20 mil PCB</a:t>
+            </a:r>
+          </a:p>
+          <a:p>
+            <a:r>
+              <a:rPr lang="en-US" dirty="0"/>
+              <a:t>With one insulating layer and 2 copper layers</a:t>
+            </a:r>
+          </a:p>
+        </p:txBody>
+      </p:sp>
+      <p:sp>
+        <p:nvSpPr>
+          <p:cNvPr id="11" name="TextBox 10">
+            <a:extLst>
+              <a:ext uri="{FF2B5EF4-FFF2-40B4-BE49-F238E27FC236}">
+                <a16:creationId xmlns:a16="http://schemas.microsoft.com/office/drawing/2014/main" id="{D7203E59-CC8F-98EC-AEF8-2A90A0B2EED6}"/>
+              </a:ext>
+            </a:extLst>
+          </p:cNvPr>
+          <p:cNvSpPr txBox="1"/>
+          <p:nvPr/>
+        </p:nvSpPr>
+        <p:spPr>
+          <a:xfrm>
+            <a:off x="5168348" y="6432605"/>
+            <a:ext cx="1720792" cy="369332"/>
+          </a:xfrm>
+          <a:prstGeom prst="rect">
+            <a:avLst/>
+          </a:prstGeom>
+          <a:noFill/>
+        </p:spPr>
+        <p:txBody>
+          <a:bodyPr wrap="none" rtlCol="0">
+            <a:spAutoFit/>
+          </a:bodyPr>
+          <a:lstStyle/>
+          <a:p>
+            <a:r>
+              <a:rPr lang="en-US" dirty="0"/>
+              <a:t>WM5394CT-ND</a:t>
+            </a:r>
+          </a:p>
+        </p:txBody>
+      </p:sp>
+      <p:sp>
+        <p:nvSpPr>
+          <p:cNvPr id="13" name="TextBox 12">
+            <a:extLst>
+              <a:ext uri="{FF2B5EF4-FFF2-40B4-BE49-F238E27FC236}">
+                <a16:creationId xmlns:a16="http://schemas.microsoft.com/office/drawing/2014/main" id="{67EF6684-B535-86CE-EEAF-A35CFDAC2012}"/>
+              </a:ext>
+            </a:extLst>
+          </p:cNvPr>
+          <p:cNvSpPr txBox="1"/>
+          <p:nvPr/>
+        </p:nvSpPr>
+        <p:spPr>
+          <a:xfrm>
+            <a:off x="5695123" y="5321037"/>
+            <a:ext cx="6094674" cy="646331"/>
+          </a:xfrm>
+          <a:prstGeom prst="rect">
+            <a:avLst/>
+          </a:prstGeom>
+          <a:noFill/>
+        </p:spPr>
+        <p:txBody>
+          <a:bodyPr wrap="square">
+            <a:spAutoFit/>
+          </a:bodyPr>
+          <a:lstStyle/>
+          <a:p>
+            <a:r>
+              <a:rPr lang="en-US" dirty="0">
+                <a:hlinkClick r:id="rId5"/>
+              </a:rPr>
+              <a:t>https://www.digikey.com/en/products/detail/molex/0734153310/2755910</a:t>
+            </a:r>
+            <a:r>
+              <a:rPr lang="en-US" dirty="0"/>
+              <a:t> </a:t>
+            </a:r>
+          </a:p>
+        </p:txBody>
+      </p:sp>
+      <p:pic>
+        <p:nvPicPr>
+          <p:cNvPr id="1026" name="Picture 2" descr="SMP Connector Plug, Male Pin 50 Ohms Surface Mount Solder">
+            <a:extLst>
+              <a:ext uri="{FF2B5EF4-FFF2-40B4-BE49-F238E27FC236}">
+                <a16:creationId xmlns:a16="http://schemas.microsoft.com/office/drawing/2014/main" id="{1AC9C9E3-52D5-3E8E-5FF8-581C17537C32}"/>
+              </a:ext>
+            </a:extLst>
+          </p:cNvPr>
+          <p:cNvPicPr>
+            <a:picLocks noChangeAspect="1" noChangeArrowheads="1"/>
+          </p:cNvPicPr>
+          <p:nvPr/>
+        </p:nvPicPr>
+        <p:blipFill>
+          <a:blip r:embed="rId6">
+            <a:extLst>
+              <a:ext uri="{28A0092B-C50C-407E-A947-70E740481C1C}">
+                <a14:useLocalDpi xmlns:a14="http://schemas.microsoft.com/office/drawing/2010/main" val="0"/>
+              </a:ext>
+            </a:extLst>
+          </a:blip>
+          <a:srcRect/>
+          <a:stretch>
+            <a:fillRect/>
+          </a:stretch>
+        </p:blipFill>
+        <p:spPr bwMode="auto">
+          <a:xfrm>
+            <a:off x="5961706" y="1833276"/>
+            <a:ext cx="2015016" cy="2015016"/>
+          </a:xfrm>
+          <a:prstGeom prst="rect">
+            <a:avLst/>
+          </a:prstGeom>
+          <a:noFill/>
+          <a:extLst>
+            <a:ext uri="{909E8E84-426E-40DD-AFC4-6F175D3DCCD1}">
+              <a14:hiddenFill xmlns:a14="http://schemas.microsoft.com/office/drawing/2010/main">
+                <a:solidFill>
+                  <a:srgbClr val="FFFFFF"/>
+                </a:solidFill>
+              </a14:hiddenFill>
+            </a:ext>
+          </a:extLst>
+        </p:spPr>
+      </p:pic>
+    </p:spTree>
+    <p:extLst>
+      <p:ext uri="{BB962C8B-B14F-4D97-AF65-F5344CB8AC3E}">
+        <p14:creationId xmlns:p14="http://schemas.microsoft.com/office/powerpoint/2010/main" val="1433773334"/>
+      </p:ext>
+    </p:extLst>
+  </p:cSld>
+  <p:clrMapOvr>
+    <a:masterClrMapping/>
+  </p:clrMapOvr>
+</p:sld>
+</file>
+
+<file path=ppt/slides/slide25.xml><?xml version="1.0" encoding="utf-8"?>
+<p:sld xmlns:a="http://schemas.openxmlformats.org/drawingml/2006/main" xmlns:r="http://schemas.openxmlformats.org/officeDocument/2006/relationships" xmlns:p="http://schemas.openxmlformats.org/presentationml/2006/main">
+  <p:cSld>
+    <p:spTree>
+      <p:nvGrpSpPr>
+        <p:cNvPr id="1" name=""/>
+        <p:cNvGrpSpPr/>
+        <p:nvPr/>
+      </p:nvGrpSpPr>
+      <p:grpSpPr>
+        <a:xfrm>
+          <a:off x="0" y="0"/>
+          <a:ext cx="0" cy="0"/>
+          <a:chOff x="0" y="0"/>
+          <a:chExt cx="0" cy="0"/>
+        </a:xfrm>
+      </p:grpSpPr>
+      <p:sp>
+        <p:nvSpPr>
+          <p:cNvPr id="2" name="Title 1">
+            <a:extLst>
+              <a:ext uri="{FF2B5EF4-FFF2-40B4-BE49-F238E27FC236}">
+                <a16:creationId xmlns:a16="http://schemas.microsoft.com/office/drawing/2014/main" id="{CE87E419-F643-0473-4762-635D51F98A3F}"/>
+              </a:ext>
+            </a:extLst>
+          </p:cNvPr>
+          <p:cNvSpPr>
+            <a:spLocks noGrp="1"/>
+          </p:cNvSpPr>
+          <p:nvPr>
+            <p:ph type="title"/>
+          </p:nvPr>
+        </p:nvSpPr>
+        <p:spPr/>
+        <p:txBody>
+          <a:bodyPr/>
+          <a:lstStyle/>
+          <a:p>
+            <a:r>
+              <a:rPr lang="en-US" dirty="0"/>
+              <a:t>M2.5 Screw and Nut</a:t>
+            </a:r>
+          </a:p>
+        </p:txBody>
+      </p:sp>
+      <p:sp>
+        <p:nvSpPr>
+          <p:cNvPr id="5" name="TextBox 4">
+            <a:extLst>
+              <a:ext uri="{FF2B5EF4-FFF2-40B4-BE49-F238E27FC236}">
+                <a16:creationId xmlns:a16="http://schemas.microsoft.com/office/drawing/2014/main" id="{F8132984-4F58-9AE7-EBAB-C20A762C1271}"/>
+              </a:ext>
+            </a:extLst>
+          </p:cNvPr>
+          <p:cNvSpPr txBox="1"/>
+          <p:nvPr/>
+        </p:nvSpPr>
+        <p:spPr>
+          <a:xfrm>
+            <a:off x="89453" y="6123543"/>
+            <a:ext cx="6094674" cy="369332"/>
+          </a:xfrm>
+          <a:prstGeom prst="rect">
+            <a:avLst/>
+          </a:prstGeom>
+          <a:noFill/>
+        </p:spPr>
+        <p:txBody>
+          <a:bodyPr wrap="square">
+            <a:spAutoFit/>
+          </a:bodyPr>
+          <a:lstStyle/>
+          <a:p>
+            <a:r>
+              <a:rPr lang="en-US" dirty="0">
+                <a:hlinkClick r:id="rId2"/>
+              </a:rPr>
+              <a:t>https://www.mcmaster.com/90928A209/</a:t>
+            </a:r>
+            <a:r>
+              <a:rPr lang="en-US" dirty="0"/>
+              <a:t> </a:t>
+            </a:r>
+          </a:p>
+        </p:txBody>
+      </p:sp>
+      <p:pic>
+        <p:nvPicPr>
+          <p:cNvPr id="7" name="Picture 6">
+            <a:extLst>
+              <a:ext uri="{FF2B5EF4-FFF2-40B4-BE49-F238E27FC236}">
+                <a16:creationId xmlns:a16="http://schemas.microsoft.com/office/drawing/2014/main" id="{DE4AB394-4F0A-4550-E62D-5E79ADB573AE}"/>
+              </a:ext>
+            </a:extLst>
+          </p:cNvPr>
+          <p:cNvPicPr>
+            <a:picLocks noChangeAspect="1"/>
+          </p:cNvPicPr>
+          <p:nvPr/>
+        </p:nvPicPr>
+        <p:blipFill>
+          <a:blip r:embed="rId3"/>
+          <a:stretch>
+            <a:fillRect/>
+          </a:stretch>
+        </p:blipFill>
+        <p:spPr>
+          <a:xfrm>
+            <a:off x="47046" y="1876507"/>
+            <a:ext cx="5096241" cy="4173465"/>
+          </a:xfrm>
+          <a:prstGeom prst="rect">
+            <a:avLst/>
+          </a:prstGeom>
+        </p:spPr>
+      </p:pic>
+      <p:sp>
+        <p:nvSpPr>
+          <p:cNvPr id="9" name="TextBox 8">
+            <a:extLst>
+              <a:ext uri="{FF2B5EF4-FFF2-40B4-BE49-F238E27FC236}">
+                <a16:creationId xmlns:a16="http://schemas.microsoft.com/office/drawing/2014/main" id="{9DCB8CAD-4F2E-875E-D38D-BAC09B88C7AA}"/>
+              </a:ext>
+            </a:extLst>
+          </p:cNvPr>
+          <p:cNvSpPr txBox="1"/>
+          <p:nvPr/>
+        </p:nvSpPr>
+        <p:spPr>
+          <a:xfrm>
+            <a:off x="6050280" y="6123543"/>
+            <a:ext cx="6094674" cy="369332"/>
+          </a:xfrm>
+          <a:prstGeom prst="rect">
+            <a:avLst/>
+          </a:prstGeom>
+          <a:noFill/>
+        </p:spPr>
+        <p:txBody>
+          <a:bodyPr wrap="square">
+            <a:spAutoFit/>
+          </a:bodyPr>
+          <a:lstStyle/>
+          <a:p>
+            <a:r>
+              <a:rPr lang="en-US" dirty="0">
+                <a:hlinkClick r:id="rId4"/>
+              </a:rPr>
+              <a:t>https://www.mcmaster.com/93187A112/</a:t>
+            </a:r>
+            <a:r>
+              <a:rPr lang="en-US" dirty="0"/>
+              <a:t> </a:t>
+            </a:r>
+          </a:p>
+        </p:txBody>
+      </p:sp>
+      <p:pic>
+        <p:nvPicPr>
+          <p:cNvPr id="11" name="Picture 10">
+            <a:extLst>
+              <a:ext uri="{FF2B5EF4-FFF2-40B4-BE49-F238E27FC236}">
+                <a16:creationId xmlns:a16="http://schemas.microsoft.com/office/drawing/2014/main" id="{AD0940DC-A8BB-CC84-4FAB-ECFC82AFCACD}"/>
+              </a:ext>
+            </a:extLst>
+          </p:cNvPr>
+          <p:cNvPicPr>
+            <a:picLocks noChangeAspect="1"/>
+          </p:cNvPicPr>
+          <p:nvPr/>
+        </p:nvPicPr>
+        <p:blipFill>
+          <a:blip r:embed="rId5"/>
+          <a:stretch>
+            <a:fillRect/>
+          </a:stretch>
+        </p:blipFill>
+        <p:spPr>
+          <a:xfrm>
+            <a:off x="6050280" y="845591"/>
+            <a:ext cx="5345130" cy="4445744"/>
+          </a:xfrm>
+          <a:prstGeom prst="rect">
+            <a:avLst/>
+          </a:prstGeom>
+        </p:spPr>
+      </p:pic>
+      <p:sp>
+        <p:nvSpPr>
+          <p:cNvPr id="12" name="TextBox 11">
+            <a:extLst>
+              <a:ext uri="{FF2B5EF4-FFF2-40B4-BE49-F238E27FC236}">
+                <a16:creationId xmlns:a16="http://schemas.microsoft.com/office/drawing/2014/main" id="{0A9716F1-644B-31DC-993D-6048A1A9DC2E}"/>
+              </a:ext>
+            </a:extLst>
+          </p:cNvPr>
+          <p:cNvSpPr txBox="1"/>
+          <p:nvPr/>
+        </p:nvSpPr>
+        <p:spPr>
+          <a:xfrm>
+            <a:off x="492980" y="2153564"/>
+            <a:ext cx="3193054" cy="369332"/>
+          </a:xfrm>
+          <a:prstGeom prst="rect">
+            <a:avLst/>
+          </a:prstGeom>
+          <a:noFill/>
+        </p:spPr>
+        <p:txBody>
+          <a:bodyPr wrap="none" rtlCol="0">
+            <a:spAutoFit/>
+          </a:bodyPr>
+          <a:lstStyle/>
+          <a:p>
+            <a:r>
+              <a:rPr lang="en-US" dirty="0"/>
+              <a:t>Clearance 2.75 mm = 108 mils</a:t>
+            </a:r>
+          </a:p>
+        </p:txBody>
+      </p:sp>
+    </p:spTree>
+    <p:extLst>
+      <p:ext uri="{BB962C8B-B14F-4D97-AF65-F5344CB8AC3E}">
+        <p14:creationId xmlns:p14="http://schemas.microsoft.com/office/powerpoint/2010/main" val="1999695950"/>
       </p:ext>
     </p:extLst>
   </p:cSld>

</xml_diff>

<commit_message>
changed to stackup like JAWS
</commit_message>
<xml_diff>
--- a/SP3T-ECAL.pptx
+++ b/SP3T-ECAL.pptx
@@ -30,6 +30,7 @@
     <p:sldId id="278" r:id="rId24"/>
     <p:sldId id="279" r:id="rId25"/>
     <p:sldId id="280" r:id="rId26"/>
+    <p:sldId id="281" r:id="rId27"/>
   </p:sldIdLst>
   <p:sldSz cx="12192000" cy="6858000"/>
   <p:notesSz cx="7023100" cy="9309100"/>
@@ -7957,6 +7958,129 @@
     <p:extLst>
       <p:ext uri="{BB962C8B-B14F-4D97-AF65-F5344CB8AC3E}">
         <p14:creationId xmlns:p14="http://schemas.microsoft.com/office/powerpoint/2010/main" val="1999695950"/>
+      </p:ext>
+    </p:extLst>
+  </p:cSld>
+  <p:clrMapOvr>
+    <a:masterClrMapping/>
+  </p:clrMapOvr>
+</p:sld>
+</file>
+
+<file path=ppt/slides/slide26.xml><?xml version="1.0" encoding="utf-8"?>
+<p:sld xmlns:a="http://schemas.openxmlformats.org/drawingml/2006/main" xmlns:r="http://schemas.openxmlformats.org/officeDocument/2006/relationships" xmlns:p="http://schemas.openxmlformats.org/presentationml/2006/main">
+  <p:cSld>
+    <p:spTree>
+      <p:nvGrpSpPr>
+        <p:cNvPr id="1" name=""/>
+        <p:cNvGrpSpPr/>
+        <p:nvPr/>
+      </p:nvGrpSpPr>
+      <p:grpSpPr>
+        <a:xfrm>
+          <a:off x="0" y="0"/>
+          <a:ext cx="0" cy="0"/>
+          <a:chOff x="0" y="0"/>
+          <a:chExt cx="0" cy="0"/>
+        </a:xfrm>
+      </p:grpSpPr>
+      <p:sp>
+        <p:nvSpPr>
+          <p:cNvPr id="2" name="Title 1">
+            <a:extLst>
+              <a:ext uri="{FF2B5EF4-FFF2-40B4-BE49-F238E27FC236}">
+                <a16:creationId xmlns:a16="http://schemas.microsoft.com/office/drawing/2014/main" id="{5C2CAFE1-AAE5-4D12-0C1B-C2F7146DAD94}"/>
+              </a:ext>
+            </a:extLst>
+          </p:cNvPr>
+          <p:cNvSpPr>
+            <a:spLocks noGrp="1"/>
+          </p:cNvSpPr>
+          <p:nvPr>
+            <p:ph type="title"/>
+          </p:nvPr>
+        </p:nvSpPr>
+        <p:spPr/>
+        <p:txBody>
+          <a:bodyPr/>
+          <a:lstStyle/>
+          <a:p>
+            <a:r>
+              <a:rPr lang="en-US" dirty="0"/>
+              <a:t>JAWS Import from </a:t>
+            </a:r>
+            <a:r>
+              <a:rPr lang="en-US" dirty="0" err="1"/>
+              <a:t>Alium</a:t>
+            </a:r>
+            <a:endParaRPr lang="en-US" dirty="0"/>
+          </a:p>
+        </p:txBody>
+      </p:sp>
+      <p:pic>
+        <p:nvPicPr>
+          <p:cNvPr id="5" name="Picture 4">
+            <a:extLst>
+              <a:ext uri="{FF2B5EF4-FFF2-40B4-BE49-F238E27FC236}">
+                <a16:creationId xmlns:a16="http://schemas.microsoft.com/office/drawing/2014/main" id="{576E3EB3-B223-6868-5191-34B4DBB07FB8}"/>
+              </a:ext>
+            </a:extLst>
+          </p:cNvPr>
+          <p:cNvPicPr>
+            <a:picLocks noChangeAspect="1"/>
+          </p:cNvPicPr>
+          <p:nvPr/>
+        </p:nvPicPr>
+        <p:blipFill>
+          <a:blip r:embed="rId2"/>
+          <a:stretch>
+            <a:fillRect/>
+          </a:stretch>
+        </p:blipFill>
+        <p:spPr>
+          <a:xfrm>
+            <a:off x="421419" y="1540740"/>
+            <a:ext cx="6048972" cy="3892844"/>
+          </a:xfrm>
+          <a:prstGeom prst="rect">
+            <a:avLst/>
+          </a:prstGeom>
+        </p:spPr>
+      </p:pic>
+      <p:pic>
+        <p:nvPicPr>
+          <p:cNvPr id="7" name="Picture 6">
+            <a:extLst>
+              <a:ext uri="{FF2B5EF4-FFF2-40B4-BE49-F238E27FC236}">
+                <a16:creationId xmlns:a16="http://schemas.microsoft.com/office/drawing/2014/main" id="{E2528407-3906-72F3-B0B8-FD35919287A6}"/>
+              </a:ext>
+            </a:extLst>
+          </p:cNvPr>
+          <p:cNvPicPr>
+            <a:picLocks noChangeAspect="1"/>
+          </p:cNvPicPr>
+          <p:nvPr/>
+        </p:nvPicPr>
+        <p:blipFill>
+          <a:blip r:embed="rId3"/>
+          <a:stretch>
+            <a:fillRect/>
+          </a:stretch>
+        </p:blipFill>
+        <p:spPr>
+          <a:xfrm>
+            <a:off x="421419" y="5433584"/>
+            <a:ext cx="11203388" cy="1123693"/>
+          </a:xfrm>
+          <a:prstGeom prst="rect">
+            <a:avLst/>
+          </a:prstGeom>
+        </p:spPr>
+      </p:pic>
+    </p:spTree>
+    <p:extLst>
+      <p:ext uri="{BB962C8B-B14F-4D97-AF65-F5344CB8AC3E}">
+        <p14:creationId xmlns:p14="http://schemas.microsoft.com/office/powerpoint/2010/main" val="3152177908"/>
       </p:ext>
     </p:extLst>
   </p:cSld>

</xml_diff>

<commit_message>
twpatron 3d assembly coming together
</commit_message>
<xml_diff>
--- a/SP3T-ECAL.pptx
+++ b/SP3T-ECAL.pptx
@@ -284,7 +284,7 @@
           <a:p>
             <a:fld id="{7053F05D-9385-4B1A-9374-4A2BEAD69DDD}" type="datetimeFigureOut">
               <a:rPr lang="en-US" smtClean="0"/>
-              <a:t>3/10/2026</a:t>
+              <a:t>3/11/2026</a:t>
             </a:fld>
             <a:endParaRPr lang="en-US"/>
           </a:p>
@@ -482,7 +482,7 @@
           <a:p>
             <a:fld id="{7053F05D-9385-4B1A-9374-4A2BEAD69DDD}" type="datetimeFigureOut">
               <a:rPr lang="en-US" smtClean="0"/>
-              <a:t>3/10/2026</a:t>
+              <a:t>3/11/2026</a:t>
             </a:fld>
             <a:endParaRPr lang="en-US"/>
           </a:p>
@@ -690,7 +690,7 @@
           <a:p>
             <a:fld id="{7053F05D-9385-4B1A-9374-4A2BEAD69DDD}" type="datetimeFigureOut">
               <a:rPr lang="en-US" smtClean="0"/>
-              <a:t>3/10/2026</a:t>
+              <a:t>3/11/2026</a:t>
             </a:fld>
             <a:endParaRPr lang="en-US"/>
           </a:p>
@@ -888,7 +888,7 @@
           <a:p>
             <a:fld id="{7053F05D-9385-4B1A-9374-4A2BEAD69DDD}" type="datetimeFigureOut">
               <a:rPr lang="en-US" smtClean="0"/>
-              <a:t>3/10/2026</a:t>
+              <a:t>3/11/2026</a:t>
             </a:fld>
             <a:endParaRPr lang="en-US"/>
           </a:p>
@@ -1163,7 +1163,7 @@
           <a:p>
             <a:fld id="{7053F05D-9385-4B1A-9374-4A2BEAD69DDD}" type="datetimeFigureOut">
               <a:rPr lang="en-US" smtClean="0"/>
-              <a:t>3/10/2026</a:t>
+              <a:t>3/11/2026</a:t>
             </a:fld>
             <a:endParaRPr lang="en-US"/>
           </a:p>
@@ -1428,7 +1428,7 @@
           <a:p>
             <a:fld id="{7053F05D-9385-4B1A-9374-4A2BEAD69DDD}" type="datetimeFigureOut">
               <a:rPr lang="en-US" smtClean="0"/>
-              <a:t>3/10/2026</a:t>
+              <a:t>3/11/2026</a:t>
             </a:fld>
             <a:endParaRPr lang="en-US"/>
           </a:p>
@@ -1840,7 +1840,7 @@
           <a:p>
             <a:fld id="{7053F05D-9385-4B1A-9374-4A2BEAD69DDD}" type="datetimeFigureOut">
               <a:rPr lang="en-US" smtClean="0"/>
-              <a:t>3/10/2026</a:t>
+              <a:t>3/11/2026</a:t>
             </a:fld>
             <a:endParaRPr lang="en-US"/>
           </a:p>
@@ -1981,7 +1981,7 @@
           <a:p>
             <a:fld id="{7053F05D-9385-4B1A-9374-4A2BEAD69DDD}" type="datetimeFigureOut">
               <a:rPr lang="en-US" smtClean="0"/>
-              <a:t>3/10/2026</a:t>
+              <a:t>3/11/2026</a:t>
             </a:fld>
             <a:endParaRPr lang="en-US"/>
           </a:p>
@@ -2094,7 +2094,7 @@
           <a:p>
             <a:fld id="{7053F05D-9385-4B1A-9374-4A2BEAD69DDD}" type="datetimeFigureOut">
               <a:rPr lang="en-US" smtClean="0"/>
-              <a:t>3/10/2026</a:t>
+              <a:t>3/11/2026</a:t>
             </a:fld>
             <a:endParaRPr lang="en-US"/>
           </a:p>
@@ -2405,7 +2405,7 @@
           <a:p>
             <a:fld id="{7053F05D-9385-4B1A-9374-4A2BEAD69DDD}" type="datetimeFigureOut">
               <a:rPr lang="en-US" smtClean="0"/>
-              <a:t>3/10/2026</a:t>
+              <a:t>3/11/2026</a:t>
             </a:fld>
             <a:endParaRPr lang="en-US"/>
           </a:p>
@@ -2693,7 +2693,7 @@
           <a:p>
             <a:fld id="{7053F05D-9385-4B1A-9374-4A2BEAD69DDD}" type="datetimeFigureOut">
               <a:rPr lang="en-US" smtClean="0"/>
-              <a:t>3/10/2026</a:t>
+              <a:t>3/11/2026</a:t>
             </a:fld>
             <a:endParaRPr lang="en-US"/>
           </a:p>
@@ -2934,7 +2934,7 @@
           <a:p>
             <a:fld id="{7053F05D-9385-4B1A-9374-4A2BEAD69DDD}" type="datetimeFigureOut">
               <a:rPr lang="en-US" smtClean="0"/>
-              <a:t>3/10/2026</a:t>
+              <a:t>3/11/2026</a:t>
             </a:fld>
             <a:endParaRPr lang="en-US"/>
           </a:p>

</xml_diff>